<commit_message>
feat: complete mandatory deliverables for Minor Project Final Presentation (full project report with code PDF, source code booklet PDF, final presentation PPTX/PDF)
</commit_message>
<xml_diff>
--- a/BCA_508_Minor_Project_Presentation_HARMONY.pptx
+++ b/BCA_508_Minor_Project_Presentation_HARMONY.pptx
@@ -3150,8 +3150,8 @@
         </p:nvSpPr>
         <p:spPr>
           <a:xfrm>
-            <a:off x="731520" y="548640"/>
-            <a:ext cx="2286000" cy="54864"/>
+            <a:off x="731520" y="502920"/>
+            <a:ext cx="2926080" cy="54864"/>
           </a:xfrm>
           <a:prstGeom prst="rect">
             <a:avLst/>
@@ -3193,8 +3193,8 @@
         </p:nvSpPr>
         <p:spPr>
           <a:xfrm>
-            <a:off x="731520" y="731520"/>
-            <a:ext cx="10698480" cy="2011680"/>
+            <a:off x="731520" y="685800"/>
+            <a:ext cx="10698480" cy="2057400"/>
           </a:xfrm>
           <a:prstGeom prst="rect">
             <a:avLst/>
@@ -3220,7 +3220,7 @@
           </a:p>
           <a:p>
             <a:pPr>
-              <a:defRPr sz="2200" b="1">
+              <a:defRPr sz="2100" b="1">
                 <a:solidFill>
                   <a:srgbClr val="10B981"/>
                 </a:solidFill>
@@ -3232,14 +3232,14 @@
           </a:p>
           <a:p>
             <a:pPr>
-              <a:defRPr sz="1300">
+              <a:defRPr sz="1200">
                 <a:solidFill>
                   <a:srgbClr val="94A3B8"/>
                 </a:solidFill>
               </a:defRPr>
             </a:pPr>
             <a:r>
-              <a:t>A Modern Full-Stack System for Automated Expense Splitting, Effort-Weighted Chore Allocation &amp; Household Transparency</a:t>
+              <a:t>Minor Project Final Presentation (BCA-508) | Full-Stack System for Expense Splitting, Effort Gamification &amp; Household Transparency</a:t>
             </a:r>
           </a:p>
         </p:txBody>
@@ -3253,7 +3253,7 @@
         <p:spPr>
           <a:xfrm>
             <a:off x="731520" y="2926080"/>
-            <a:ext cx="5120640" cy="3108960"/>
+            <a:ext cx="5120640" cy="3154680"/>
           </a:xfrm>
           <a:prstGeom prst="roundRect">
             <a:avLst/>
@@ -3333,7 +3333,7 @@
         <p:spPr>
           <a:xfrm>
             <a:off x="914400" y="3383280"/>
-            <a:ext cx="4754880" cy="2468880"/>
+            <a:ext cx="4754880" cy="2560320"/>
           </a:xfrm>
           <a:prstGeom prst="rect">
             <a:avLst/>
@@ -3455,7 +3455,7 @@
                   <a:srgbClr val="F8FAFC"/>
                 </a:solidFill>
               </a:rPr>
-              <a:t>Panel 2 (Room DG4) | 1st Review: 24 Oct 2026
+              <a:t>Panel 2 (Room DG4) | Final Presentation Day
 </a:t>
             </a:r>
           </a:p>
@@ -3489,7 +3489,7 @@
         <p:spPr>
           <a:xfrm>
             <a:off x="6126480" y="2926080"/>
-            <a:ext cx="5303520" cy="3108960"/>
+            <a:ext cx="5303520" cy="3154680"/>
           </a:xfrm>
           <a:prstGeom prst="roundRect">
             <a:avLst/>
@@ -3555,7 +3555,7 @@
               </a:defRPr>
             </a:pPr>
             <a:r>
-              <a:t>MANDATORY REVIEW 1 LIVE LINKS</a:t>
+              <a:t>MANDATORY FINAL PRESENTATION LIVE LINKS</a:t>
             </a:r>
           </a:p>
         </p:txBody>
@@ -3569,7 +3569,7 @@
         <p:spPr>
           <a:xfrm>
             <a:off x="6309360" y="3383280"/>
-            <a:ext cx="4937760" cy="2468880"/>
+            <a:ext cx="4937760" cy="2560320"/>
           </a:xfrm>
           <a:prstGeom prst="rect">
             <a:avLst/>
@@ -3590,7 +3590,7 @@
               </a:defRPr>
             </a:pPr>
             <a:r>
-              <a:t>Teacher &amp; Panel Clickable Access (As Mandated for Review 1):</a:t>
+              <a:t>Clickable Production Access (As Mandated by Department):</a:t>
             </a:r>
           </a:p>
           <a:p>
@@ -3601,7 +3601,7 @@
                 </a:solidFill>
               </a:rPr>
               <a:t>
-[LIVE PRODUCTION APP] </a:t>
+[LIVE PRODUCTION DEPLOYMENT] </a:t>
             </a:r>
             <a:r>
               <a:rPr sz="1300" b="1" u="sng">
@@ -3621,7 +3621,7 @@
                   <a:srgbClr val="8B5CF6"/>
                 </a:solidFill>
               </a:rPr>
-              <a:t>[PUBLIC GITHUB REPOSITORY] </a:t>
+              <a:t>[PUBLIC GITHUB REPOSITORY &amp; CODE] </a:t>
             </a:r>
             <a:r>
               <a:rPr sz="1300" b="1" u="sng">
@@ -3642,7 +3642,7 @@
                 </a:solidFill>
               </a:rPr>
               <a:t>Architecture: React 18 + Node.js/Express + PostgreSQL
-Offline-Resilient Failover Layer Active for Zero-Downtime Viva.</a:t>
+Offline-Resilient Failover Layer Active for Zero-Downtime Defense.</a:t>
             </a:r>
           </a:p>
         </p:txBody>
@@ -3677,7 +3677,7 @@
               </a:defRPr>
             </a:pPr>
             <a:r>
-              <a:t>HARMONY | Candidate: Lakshya Shukla (240919106121) | Guide: Mr. Nihal Kumar | IMS Noida (Panel 2 - DG4) | Slide 1 of 12</a:t>
+              <a:t>HARMONY | Candidate: Lakshya Shukla (240919106121) | Guide: Mr. Nihal Kumar | IMS Noida (Panel 2 - Room DG4) | Slide 1 of 12</a:t>
             </a:r>
           </a:p>
         </p:txBody>
@@ -3773,7 +3773,7 @@
               </a:defRPr>
             </a:pPr>
             <a:r>
-              <a:t>BCA-508 MINOR PROJECT REVIEW 1</a:t>
+              <a:t>BCA-508 MINOR PROJECT FINAL PRESENTATION</a:t>
             </a:r>
           </a:p>
         </p:txBody>
@@ -3808,7 +3808,7 @@
               </a:defRPr>
             </a:pPr>
             <a:r>
-              <a:t>Quality Assurance, Testing &amp; Viva Defense</a:t>
+              <a:t>Quality Assurance, Testing &amp; Presentation Defense</a:t>
             </a:r>
           </a:p>
         </p:txBody>
@@ -4322,7 +4322,7 @@
               </a:defRPr>
             </a:pPr>
             <a:r>
-              <a:t>HARMONY | Candidate: Lakshya Shukla (240919106121) | Guide: Mr. Nihal Kumar | IMS Noida (Panel 2 - DG4) | Slide 10 of 12</a:t>
+              <a:t>HARMONY | Candidate: Lakshya Shukla (240919106121) | Guide: Mr. Nihal Kumar | IMS Noida (Panel 2 - Room DG4) | Slide 10 of 12</a:t>
             </a:r>
           </a:p>
         </p:txBody>
@@ -4418,7 +4418,7 @@
               </a:defRPr>
             </a:pPr>
             <a:r>
-              <a:t>BCA-508 MINOR PROJECT REVIEW 1</a:t>
+              <a:t>BCA-508 MINOR PROJECT FINAL PRESENTATION</a:t>
             </a:r>
           </a:p>
         </p:txBody>
@@ -4453,7 +4453,7 @@
               </a:defRPr>
             </a:pPr>
             <a:r>
-              <a:t>Cloud Deployment Architecture &amp; Mandatory Live Links</a:t>
+              <a:t>Cloud Deployment Topology &amp; Mandatory Live Links</a:t>
             </a:r>
           </a:p>
         </p:txBody>
@@ -4611,7 +4611,7 @@
               </a:defRPr>
             </a:pPr>
             <a:r>
-              <a:t>Deployment Architecture Breakdown (Mandated by SOIT Department for 24 Oct Review 1):</a:t>
+              <a:t>Deployment Architecture Breakdown (Mandated by Department for Final Presentation):</a:t>
             </a:r>
           </a:p>
           <a:p>
@@ -4737,7 +4737,7 @@
               </a:defRPr>
             </a:pPr>
             <a:r>
-              <a:t>HARMONY | Candidate: Lakshya Shukla (240919106121) | Guide: Mr. Nihal Kumar | IMS Noida (Panel 2 - DG4) | Slide 11 of 12</a:t>
+              <a:t>HARMONY | Candidate: Lakshya Shukla (240919106121) | Guide: Mr. Nihal Kumar | IMS Noida (Panel 2 - Room DG4) | Slide 11 of 12</a:t>
             </a:r>
           </a:p>
         </p:txBody>
@@ -4833,7 +4833,7 @@
               </a:defRPr>
             </a:pPr>
             <a:r>
-              <a:t>MILESTONE 1 STATUS: 100% COMPLETE</a:t>
+              <a:t>MINOR PROJECT STATUS: 100% COMPLETE &amp; DEPLOYED</a:t>
             </a:r>
           </a:p>
         </p:txBody>
@@ -4868,7 +4868,7 @@
               </a:defRPr>
             </a:pPr>
             <a:r>
-              <a:t>Milestone Summary &amp; Viva Examination Q&amp;A</a:t>
+              <a:t>Final Presentation Summary &amp; Viva Defense</a:t>
             </a:r>
           </a:p>
         </p:txBody>
@@ -4991,7 +4991,7 @@
               </a:defRPr>
             </a:pPr>
             <a:r>
-              <a:t>DELIVERABLES CHECKLIST</a:t>
+              <a:t>FINAL DELIVERABLES READY</a:t>
             </a:r>
           </a:p>
         </p:txBody>
@@ -5026,52 +5026,43 @@
               </a:defRPr>
             </a:pPr>
             <a:r>
-              <a:t>Academic Milestones Completed:</a:t>
-            </a:r>
-            <a:br/>
-            <a:br/>
-            <a:r>
-              <a:t>[X] Formal Project Synopsis (BCA-508):</a:t>
-            </a:r>
-            <a:br/>
-            <a:r>
-              <a:t>    29-page comprehensive document printed per CCSU format with Cannock Private Limited certificate &amp; DFD diagrams.</a:t>
-            </a:r>
-            <a:br/>
-            <a:br/>
-            <a:r>
-              <a:t>[X] System Architecture &amp; Database Design:</a:t>
-            </a:r>
-            <a:br/>
-            <a:r>
-              <a:t>    Complete 3NF relational schema, DFD Levels 0/1/2, and ERD.</a:t>
-            </a:r>
-            <a:br/>
-            <a:br/>
-            <a:r>
-              <a:t>[X] Functional Full-Stack Application:</a:t>
-            </a:r>
-            <a:br/>
-            <a:r>
-              <a:t>    React SPA + Express API + PostgreSQL backend operational.</a:t>
-            </a:r>
-            <a:br/>
-            <a:br/>
-            <a:r>
-              <a:t>[X] Public GitHub Repository:</a:t>
-            </a:r>
-            <a:br/>
-            <a:r>
-              <a:t>    Clean source tree with documentation &amp; seed scripts.</a:t>
-            </a:r>
-            <a:br/>
-            <a:br/>
-            <a:r>
-              <a:t>[X] Cloud Deployment &amp; Live Link:</a:t>
-            </a:r>
-            <a:br/>
-            <a:r>
-              <a:t>    Accessible via browser on any device.</a:t>
+              <a:t>Mandatory Submissions for Panel 2:</a:t>
+            </a:r>
+            <a:br/>
+            <a:br/>
+            <a:r>
+              <a:t>[X] PDF of Project Along with Code:</a:t>
+            </a:r>
+            <a:br/>
+            <a:r>
+              <a:t>    Comprehensive documentation with Cannock Pvt Ltd certificate, DFDs, ERD, and Section 12 full source code appendix.</a:t>
+            </a:r>
+            <a:br/>
+            <a:br/>
+            <a:r>
+              <a:t>[X] Project Deployment Link:</a:t>
+            </a:r>
+            <a:br/>
+            <a:r>
+              <a:t>    Production web app live on Vercel with resilient client fallback.</a:t>
+            </a:r>
+            <a:br/>
+            <a:br/>
+            <a:r>
+              <a:t>[X] PPT for Presentation (Mandatory):</a:t>
+            </a:r>
+            <a:br/>
+            <a:r>
+              <a:t>    12-slide comprehensive presentation with live clickable links.</a:t>
+            </a:r>
+            <a:br/>
+            <a:br/>
+            <a:r>
+              <a:t>[X] GitHub Source Code Repository:</a:t>
+            </a:r>
+            <a:br/>
+            <a:r>
+              <a:t>    Publicly accessible at github.com/lakshya212/HARMONY.</a:t>
             </a:r>
           </a:p>
         </p:txBody>
@@ -5151,7 +5142,7 @@
               </a:defRPr>
             </a:pPr>
             <a:r>
-              <a:t>READY FOR PANEL 2 REVIEW</a:t>
+              <a:t>PANEL 2 VIVA PRESENTATION</a:t>
             </a:r>
           </a:p>
         </p:txBody>
@@ -5221,7 +5212,7 @@
             <a:br/>
             <a:br/>
             <a:r>
-              <a:t>Open for Questions from Panel 2:</a:t>
+              <a:t>Open for Final Presentation Questions from Panel 2:</a:t>
             </a:r>
             <a:br/>
             <a:r>
@@ -5264,7 +5255,7 @@
               </a:defRPr>
             </a:pPr>
             <a:r>
-              <a:t>HARMONY | Candidate: Lakshya Shukla (240919106121) | Guide: Mr. Nihal Kumar | IMS Noida (Panel 2 - DG4) | Slide 12 of 12</a:t>
+              <a:t>HARMONY | Candidate: Lakshya Shukla (240919106121) | Guide: Mr. Nihal Kumar | IMS Noida (Panel 2 - Room DG4) | Slide 12 of 12</a:t>
             </a:r>
           </a:p>
         </p:txBody>
@@ -5360,7 +5351,7 @@
               </a:defRPr>
             </a:pPr>
             <a:r>
-              <a:t>BCA-508 MINOR PROJECT REVIEW 1</a:t>
+              <a:t>BCA-508 MINOR PROJECT FINAL PRESENTATION</a:t>
             </a:r>
           </a:p>
         </p:txBody>
@@ -5558,12 +5549,12 @@
             <a:br/>
             <a:br/>
             <a:r>
-              <a:t>• Asymmetric Financial Burden: Flatmates often lose track of who paid for groceries, utilities, and internet bills, causing awkward disputes.</a:t>
-            </a:r>
-            <a:br/>
-            <a:br/>
-            <a:r>
-              <a:t>• The 'Chore Trap': Traditional tracking ignores effort disparity (e.g., taking out trash vs deep cleaning bathroom treated equally).</a:t>
+              <a:t>• Asymmetric Financial Burden: Flatmates and multi-earner households frequently lose track of who paid for groceries, utilities, and internet bills, causing awkward disputes.</a:t>
+            </a:r>
+            <a:br/>
+            <a:br/>
+            <a:r>
+              <a:t>• The 'Chore Trap': Traditional chore tracking ignores effort disparity (e.g., taking out trash vs deep cleaning bathroom treated equally).</a:t>
             </a:r>
             <a:br/>
             <a:br/>
@@ -5838,7 +5829,7 @@
             <a:br/>
             <a:br/>
             <a:r>
-              <a:t>• Defensive Reliability: Dual-mode data resilience preventing viva failure during network outages.</a:t>
+              <a:t>• Defensive Reliability: Dual-mode data resilience preventing presentation failure during network outages.</a:t>
             </a:r>
           </a:p>
         </p:txBody>
@@ -5873,7 +5864,7 @@
               </a:defRPr>
             </a:pPr>
             <a:r>
-              <a:t>HARMONY | Candidate: Lakshya Shukla (240919106121) | Guide: Mr. Nihal Kumar | IMS Noida (Panel 2 - DG4) | Slide 2 of 12</a:t>
+              <a:t>HARMONY | Candidate: Lakshya Shukla (240919106121) | Guide: Mr. Nihal Kumar | IMS Noida (Panel 2 - Room DG4) | Slide 2 of 12</a:t>
             </a:r>
           </a:p>
         </p:txBody>
@@ -5969,7 +5960,7 @@
               </a:defRPr>
             </a:pPr>
             <a:r>
-              <a:t>BCA-508 MINOR PROJECT REVIEW 1</a:t>
+              <a:t>BCA-508 MINOR PROJECT FINAL PRESENTATION</a:t>
             </a:r>
           </a:p>
         </p:txBody>
@@ -6267,7 +6258,7 @@
               </a:defRPr>
             </a:pPr>
             <a:r>
-              <a:t>HARMONY | Candidate: Lakshya Shukla (240919106121) | Guide: Mr. Nihal Kumar | IMS Noida (Panel 2 - DG4) | Slide 3 of 12</a:t>
+              <a:t>HARMONY | Candidate: Lakshya Shukla (240919106121) | Guide: Mr. Nihal Kumar | IMS Noida (Panel 2 - Room DG4) | Slide 3 of 12</a:t>
             </a:r>
           </a:p>
         </p:txBody>
@@ -6363,7 +6354,7 @@
               </a:defRPr>
             </a:pPr>
             <a:r>
-              <a:t>BCA-508 MINOR PROJECT REVIEW 1</a:t>
+              <a:t>BCA-508 MINOR PROJECT FINAL PRESENTATION</a:t>
             </a:r>
           </a:p>
         </p:txBody>
@@ -6754,7 +6745,7 @@
               </a:defRPr>
             </a:pPr>
             <a:r>
-              <a:t>HARMONY | Candidate: Lakshya Shukla (240919106121) | Guide: Mr. Nihal Kumar | IMS Noida (Panel 2 - DG4) | Slide 4 of 12</a:t>
+              <a:t>HARMONY | Candidate: Lakshya Shukla (240919106121) | Guide: Mr. Nihal Kumar | IMS Noida (Panel 2 - Room DG4) | Slide 4 of 12</a:t>
             </a:r>
           </a:p>
         </p:txBody>
@@ -6850,7 +6841,7 @@
               </a:defRPr>
             </a:pPr>
             <a:r>
-              <a:t>BCA-508 MINOR PROJECT REVIEW 1</a:t>
+              <a:t>BCA-508 MINOR PROJECT FINAL PRESENTATION</a:t>
             </a:r>
           </a:p>
         </p:txBody>
@@ -7161,7 +7152,7 @@
               </a:defRPr>
             </a:pPr>
             <a:r>
-              <a:t>HARMONY | Candidate: Lakshya Shukla (240919106121) | Guide: Mr. Nihal Kumar | IMS Noida (Panel 2 - DG4) | Slide 5 of 12</a:t>
+              <a:t>HARMONY | Candidate: Lakshya Shukla (240919106121) | Guide: Mr. Nihal Kumar | IMS Noida (Panel 2 - Room DG4) | Slide 5 of 12</a:t>
             </a:r>
           </a:p>
         </p:txBody>
@@ -7257,7 +7248,7 @@
               </a:defRPr>
             </a:pPr>
             <a:r>
-              <a:t>BCA-508 MINOR PROJECT REVIEW 1</a:t>
+              <a:t>BCA-508 MINOR PROJECT FINAL PRESENTATION</a:t>
             </a:r>
           </a:p>
         </p:txBody>
@@ -7685,7 +7676,7 @@
               </a:defRPr>
             </a:pPr>
             <a:r>
-              <a:t>HARMONY | Candidate: Lakshya Shukla (240919106121) | Guide: Mr. Nihal Kumar | IMS Noida (Panel 2 - DG4) | Slide 6 of 12</a:t>
+              <a:t>HARMONY | Candidate: Lakshya Shukla (240919106121) | Guide: Mr. Nihal Kumar | IMS Noida (Panel 2 - Room DG4) | Slide 6 of 12</a:t>
             </a:r>
           </a:p>
         </p:txBody>
@@ -7781,7 +7772,7 @@
               </a:defRPr>
             </a:pPr>
             <a:r>
-              <a:t>BCA-508 MINOR PROJECT REVIEW 1</a:t>
+              <a:t>BCA-508 MINOR PROJECT FINAL PRESENTATION</a:t>
             </a:r>
           </a:p>
         </p:txBody>
@@ -8187,7 +8178,7 @@
               </a:defRPr>
             </a:pPr>
             <a:r>
-              <a:t>HARMONY | Candidate: Lakshya Shukla (240919106121) | Guide: Mr. Nihal Kumar | IMS Noida (Panel 2 - DG4) | Slide 7 of 12</a:t>
+              <a:t>HARMONY | Candidate: Lakshya Shukla (240919106121) | Guide: Mr. Nihal Kumar | IMS Noida (Panel 2 - Room DG4) | Slide 7 of 12</a:t>
             </a:r>
           </a:p>
         </p:txBody>
@@ -8283,7 +8274,7 @@
               </a:defRPr>
             </a:pPr>
             <a:r>
-              <a:t>BCA-508 MINOR PROJECT REVIEW 1</a:t>
+              <a:t>BCA-508 MINOR PROJECT FINAL PRESENTATION</a:t>
             </a:r>
           </a:p>
         </p:txBody>
@@ -8674,7 +8665,7 @@
               </a:defRPr>
             </a:pPr>
             <a:r>
-              <a:t>HARMONY | Candidate: Lakshya Shukla (240919106121) | Guide: Mr. Nihal Kumar | IMS Noida (Panel 2 - DG4) | Slide 8 of 12</a:t>
+              <a:t>HARMONY | Candidate: Lakshya Shukla (240919106121) | Guide: Mr. Nihal Kumar | IMS Noida (Panel 2 - Room DG4) | Slide 8 of 12</a:t>
             </a:r>
           </a:p>
         </p:txBody>
@@ -8770,7 +8761,7 @@
               </a:defRPr>
             </a:pPr>
             <a:r>
-              <a:t>BCA-508 MINOR PROJECT REVIEW 1</a:t>
+              <a:t>BCA-508 MINOR PROJECT FINAL PRESENTATION</a:t>
             </a:r>
           </a:p>
         </p:txBody>
@@ -9066,7 +9057,7 @@
               </a:defRPr>
             </a:pPr>
             <a:r>
-              <a:t>HARMONY | Candidate: Lakshya Shukla (240919106121) | Guide: Mr. Nihal Kumar | IMS Noida (Panel 2 - DG4) | Slide 9 of 12</a:t>
+              <a:t>HARMONY | Candidate: Lakshya Shukla (240919106121) | Guide: Mr. Nihal Kumar | IMS Noida (Panel 2 - Room DG4) | Slide 9 of 12</a:t>
             </a:r>
           </a:p>
         </p:txBody>

</xml_diff>

<commit_message>
feat: complete master academic deliverables for BCA-508 final presentation (GitHub Pages deployment, 14-slide PPTX, 57-page report with code)
</commit_message>
<xml_diff>
--- a/BCA_508_Minor_Project_Presentation_HARMONY.pptx
+++ b/BCA_508_Minor_Project_Presentation_HARMONY.pptx
@@ -17,6 +17,8 @@
     <p:sldId id="265" r:id="rId16"/>
     <p:sldId id="266" r:id="rId17"/>
     <p:sldId id="267" r:id="rId18"/>
+    <p:sldId id="268" r:id="rId19"/>
+    <p:sldId id="269" r:id="rId20"/>
   </p:sldIdLst>
   <p:sldSz cx="12191695" cy="6858000" type="screen4x3"/>
   <p:notesSz cx="6858000" cy="9144000"/>
@@ -3239,7 +3241,7 @@
               </a:defRPr>
             </a:pPr>
             <a:r>
-              <a:t>Minor Project Final Presentation (BCA-508) | Full-Stack System for Expense Splitting, Effort Gamification &amp; Household Transparency</a:t>
+              <a:t>Minor Project Final Presentation (BCA-508) | Full-Stack System for Automated Expense Splitting, Effort Gamification &amp; Household Transparency</a:t>
             </a:r>
           </a:p>
         </p:txBody>
@@ -3312,7 +3314,7 @@
           <a:lstStyle/>
           <a:p>
             <a:pPr>
-              <a:defRPr sz="1400" b="1">
+              <a:defRPr sz="1300" b="1">
                 <a:solidFill>
                   <a:srgbClr val="06B6D4"/>
                 </a:solidFill>
@@ -3548,7 +3550,7 @@
           <a:lstStyle/>
           <a:p>
             <a:pPr>
-              <a:defRPr sz="1400" b="1">
+              <a:defRPr sz="1300" b="1">
                 <a:solidFill>
                   <a:srgbClr val="06B6D4"/>
                 </a:solidFill>
@@ -3583,7 +3585,7 @@
           <a:lstStyle/>
           <a:p>
             <a:pPr>
-              <a:defRPr sz="1100" i="1">
+              <a:defRPr sz="1050" i="1">
                 <a:solidFill>
                   <a:srgbClr val="94A3B8"/>
                 </a:solidFill>
@@ -3595,28 +3597,48 @@
           </a:p>
           <a:p>
             <a:r>
-              <a:rPr sz="1200" b="1">
+              <a:rPr sz="1100" b="1">
                 <a:solidFill>
                   <a:srgbClr val="10B981"/>
                 </a:solidFill>
               </a:rPr>
               <a:t>
-[LIVE PRODUCTION DEPLOYMENT] </a:t>
-            </a:r>
-            <a:r>
-              <a:rPr sz="1300" b="1" u="sng">
+[LIVE GITHUB PAGES] </a:t>
+            </a:r>
+            <a:r>
+              <a:rPr sz="1200" b="1" u="sng">
                 <a:solidFill>
                   <a:srgbClr val="06B6D4"/>
                 </a:solidFill>
                 <a:hlinkClick r:id="rId2"/>
               </a:rPr>
-              <a:t>Click to Open Live HARMONY Web App
+              <a:t>lakshya212.github.io/HARMONY
 </a:t>
             </a:r>
           </a:p>
           <a:p>
             <a:r>
-              <a:rPr sz="1200" b="1">
+              <a:rPr sz="1100" b="1">
+                <a:solidFill>
+                  <a:srgbClr val="10B981"/>
+                </a:solidFill>
+              </a:rPr>
+              <a:t>[LIVE VERCEL DEPLOYMENT] </a:t>
+            </a:r>
+            <a:r>
+              <a:rPr sz="1200" b="1" u="sng">
+                <a:solidFill>
+                  <a:srgbClr val="06B6D4"/>
+                </a:solidFill>
+                <a:hlinkClick r:id="rId3"/>
+              </a:rPr>
+              <a:t>harmony-household.vercel.app
+</a:t>
+            </a:r>
+          </a:p>
+          <a:p>
+            <a:r>
+              <a:rPr sz="1100" b="1">
                 <a:solidFill>
                   <a:srgbClr val="8B5CF6"/>
                 </a:solidFill>
@@ -3624,27 +3646,16 @@
               <a:t>[PUBLIC GITHUB REPOSITORY &amp; CODE] </a:t>
             </a:r>
             <a:r>
-              <a:rPr sz="1300" b="1" u="sng">
+              <a:rPr sz="1200" b="1" u="sng">
                 <a:solidFill>
                   <a:srgbClr val="06B6D4"/>
                 </a:solidFill>
-                <a:hlinkClick r:id="rId3"/>
+                <a:hlinkClick r:id="rId4"/>
               </a:rPr>
               <a:t>github.com/lakshya212/HARMONY
 </a:t>
             </a:r>
           </a:p>
-          <a:p>
-            <a:r>
-              <a:rPr sz="1000">
-                <a:solidFill>
-                  <a:srgbClr val="F59E0B"/>
-                </a:solidFill>
-              </a:rPr>
-              <a:t>Architecture: React 18 + Node.js/Express + PostgreSQL
-Offline-Resilient Failover Layer Active for Zero-Downtime Defense.</a:t>
-            </a:r>
-          </a:p>
         </p:txBody>
       </p:sp>
       <p:sp>
@@ -3677,7 +3688,7 @@
               </a:defRPr>
             </a:pPr>
             <a:r>
-              <a:t>HARMONY | Candidate: Lakshya Shukla (240919106121) | Guide: Mr. Nihal Kumar | IMS Noida (Panel 2 - Room DG4) | Slide 1 of 12</a:t>
+              <a:t>HARMONY | Candidate: Lakshya Shukla (240919106121) | Guide: Mr. Nihal Kumar | IMS Noida (Panel 2 - Room DG4) | Slide 1 of 14</a:t>
             </a:r>
           </a:p>
         </p:txBody>
@@ -3801,14 +3812,14 @@
           <a:lstStyle/>
           <a:p>
             <a:pPr>
-              <a:defRPr sz="2400" b="1">
+              <a:defRPr sz="2300" b="1">
                 <a:solidFill>
                   <a:srgbClr val="F8FAFC"/>
                 </a:solidFill>
               </a:defRPr>
             </a:pPr>
             <a:r>
-              <a:t>Quality Assurance, Testing &amp; Presentation Defense</a:t>
+              <a:t>Modern UI Design &amp; Interactive Interface</a:t>
             </a:r>
           </a:p>
         </p:txBody>
@@ -3856,16 +3867,64 @@
           </a:p>
         </p:txBody>
       </p:sp>
-      <p:sp>
-        <p:nvSpPr>
-          <p:cNvPr id="6" name="Rounded Rectangle 5"/>
+      <p:pic>
+        <p:nvPicPr>
+          <p:cNvPr id="6" name="Picture 5" descr="ui_landing.png"/>
+          <p:cNvPicPr>
+            <a:picLocks noChangeAspect="1"/>
+          </p:cNvPicPr>
+          <p:nvPr/>
+        </p:nvPicPr>
+        <p:blipFill>
+          <a:blip r:embed="rId2"/>
+          <a:stretch>
+            <a:fillRect/>
+          </a:stretch>
+        </p:blipFill>
+        <p:spPr>
+          <a:xfrm>
+            <a:off x="731520" y="1645920"/>
+            <a:ext cx="5120640" cy="2926080"/>
+          </a:xfrm>
+          <a:prstGeom prst="rect">
+            <a:avLst/>
+          </a:prstGeom>
+        </p:spPr>
+      </p:pic>
+      <p:pic>
+        <p:nvPicPr>
+          <p:cNvPr id="7" name="Picture 6" descr="ui_dashboard.png"/>
+          <p:cNvPicPr>
+            <a:picLocks noChangeAspect="1"/>
+          </p:cNvPicPr>
+          <p:nvPr/>
+        </p:nvPicPr>
+        <p:blipFill>
+          <a:blip r:embed="rId3"/>
+          <a:stretch>
+            <a:fillRect/>
+          </a:stretch>
+        </p:blipFill>
+        <p:spPr>
+          <a:xfrm>
+            <a:off x="6217920" y="1645920"/>
+            <a:ext cx="5212080" cy="2926080"/>
+          </a:xfrm>
+          <a:prstGeom prst="rect">
+            <a:avLst/>
+          </a:prstGeom>
+        </p:spPr>
+      </p:pic>
+      <p:sp>
+        <p:nvSpPr>
+          <p:cNvPr id="8" name="Rounded Rectangle 7"/>
           <p:cNvSpPr/>
           <p:nvPr/>
         </p:nvSpPr>
         <p:spPr>
           <a:xfrm>
-            <a:off x="731520" y="1645920"/>
-            <a:ext cx="3291840" cy="4480560"/>
+            <a:off x="731520" y="4754880"/>
+            <a:ext cx="5120640" cy="1463040"/>
           </a:xfrm>
           <a:prstGeom prst="roundRect">
             <a:avLst/>
@@ -3903,14 +3962,14 @@
       </p:sp>
       <p:sp>
         <p:nvSpPr>
-          <p:cNvPr id="7" name="TextBox 6"/>
+          <p:cNvPr id="9" name="TextBox 8"/>
           <p:cNvSpPr txBox="1"/>
           <p:nvPr/>
         </p:nvSpPr>
         <p:spPr>
           <a:xfrm>
-            <a:off x="914400" y="1783080"/>
-            <a:ext cx="2926080" cy="365760"/>
+            <a:off x="914400" y="4892040"/>
+            <a:ext cx="4754880" cy="365760"/>
           </a:xfrm>
           <a:prstGeom prst="rect">
             <a:avLst/>
@@ -3924,28 +3983,28 @@
           <a:lstStyle/>
           <a:p>
             <a:pPr>
-              <a:defRPr sz="1400" b="1">
+              <a:defRPr sz="1300" b="1">
                 <a:solidFill>
                   <a:srgbClr val="06B6D4"/>
                 </a:solidFill>
               </a:defRPr>
             </a:pPr>
             <a:r>
-              <a:t>TEST SUITE EXECUTION</a:t>
-            </a:r>
-          </a:p>
-        </p:txBody>
-      </p:sp>
-      <p:sp>
-        <p:nvSpPr>
-          <p:cNvPr id="8" name="TextBox 7"/>
+              <a:t>LANDING PAGE &amp; ONBOARDING</a:t>
+            </a:r>
+          </a:p>
+        </p:txBody>
+      </p:sp>
+      <p:sp>
+        <p:nvSpPr>
+          <p:cNvPr id="10" name="TextBox 9"/>
           <p:cNvSpPr txBox="1"/>
           <p:nvPr/>
         </p:nvSpPr>
         <p:spPr>
           <a:xfrm>
-            <a:off x="914400" y="2194560"/>
-            <a:ext cx="2926080" cy="3749039"/>
+            <a:off x="914400" y="5120640"/>
+            <a:ext cx="4754880" cy="1005840"/>
           </a:xfrm>
           <a:prstGeom prst="rect">
             <a:avLst/>
@@ -3959,64 +4018,28 @@
           <a:lstStyle/>
           <a:p>
             <a:pPr>
-              <a:defRPr sz="1050">
+              <a:defRPr sz="1000">
                 <a:solidFill>
                   <a:srgbClr val="F8FAFC"/>
                 </a:solidFill>
               </a:defRPr>
             </a:pPr>
             <a:r>
-              <a:t>Verified Test Cases:</a:t>
-            </a:r>
-            <a:br/>
-            <a:br/>
-            <a:r>
-              <a:t>• Auth Verification:</a:t>
-            </a:r>
-            <a:br/>
-            <a:r>
-              <a:t>  Valid login, wrong credentials, session token persistence.</a:t>
-            </a:r>
-            <a:br/>
-            <a:br/>
-            <a:r>
-              <a:t>• Ledger Verification:</a:t>
-            </a:r>
-            <a:br/>
-            <a:r>
-              <a:t>  Zero-sum test: Sum of all net balances strictly equals 0.</a:t>
-            </a:r>
-            <a:br/>
-            <a:br/>
-            <a:r>
-              <a:t>• Task Life Cycle:</a:t>
-            </a:r>
-            <a:br/>
-            <a:r>
-              <a:t>  Pending -&gt; In-Progress -&gt; Completed -&gt; Point Increment.</a:t>
-            </a:r>
-            <a:br/>
-            <a:br/>
-            <a:r>
-              <a:t>• Edge-Case Handling:</a:t>
-            </a:r>
-            <a:br/>
-            <a:r>
-              <a:t>  Zero-amount expense rejected; duplicate member prevention.</a:t>
-            </a:r>
-          </a:p>
-        </p:txBody>
-      </p:sp>
-      <p:sp>
-        <p:nvSpPr>
-          <p:cNvPr id="9" name="Rounded Rectangle 8"/>
+              <a:t>Clean, professional dark-mode design highlighting core value propositions, feature highlights, and frictionless authentication.</a:t>
+            </a:r>
+          </a:p>
+        </p:txBody>
+      </p:sp>
+      <p:sp>
+        <p:nvSpPr>
+          <p:cNvPr id="11" name="Rounded Rectangle 10"/>
           <p:cNvSpPr/>
           <p:nvPr/>
         </p:nvSpPr>
         <p:spPr>
           <a:xfrm>
-            <a:off x="4389120" y="1645920"/>
-            <a:ext cx="3291840" cy="4480560"/>
+            <a:off x="6217920" y="4754880"/>
+            <a:ext cx="5212080" cy="1463040"/>
           </a:xfrm>
           <a:prstGeom prst="roundRect">
             <a:avLst/>
@@ -4054,14 +4077,14 @@
       </p:sp>
       <p:sp>
         <p:nvSpPr>
-          <p:cNvPr id="10" name="TextBox 9"/>
+          <p:cNvPr id="12" name="TextBox 11"/>
           <p:cNvSpPr txBox="1"/>
           <p:nvPr/>
         </p:nvSpPr>
         <p:spPr>
           <a:xfrm>
-            <a:off x="4572000" y="1783080"/>
-            <a:ext cx="2926080" cy="365760"/>
+            <a:off x="6400800" y="4892040"/>
+            <a:ext cx="4846320" cy="365760"/>
           </a:xfrm>
           <a:prstGeom prst="rect">
             <a:avLst/>
@@ -4075,28 +4098,28 @@
           <a:lstStyle/>
           <a:p>
             <a:pPr>
-              <a:defRPr sz="1400" b="1">
+              <a:defRPr sz="1300" b="1">
                 <a:solidFill>
                   <a:srgbClr val="06B6D4"/>
                 </a:solidFill>
               </a:defRPr>
             </a:pPr>
             <a:r>
-              <a:t>OFFLINE RESILIENCE</a:t>
-            </a:r>
-          </a:p>
-        </p:txBody>
-      </p:sp>
-      <p:sp>
-        <p:nvSpPr>
-          <p:cNvPr id="11" name="TextBox 10"/>
+              <a:t>ROOMMATE LIVE DASHBOARD</a:t>
+            </a:r>
+          </a:p>
+        </p:txBody>
+      </p:sp>
+      <p:sp>
+        <p:nvSpPr>
+          <p:cNvPr id="13" name="TextBox 12"/>
           <p:cNvSpPr txBox="1"/>
           <p:nvPr/>
         </p:nvSpPr>
         <p:spPr>
           <a:xfrm>
-            <a:off x="4572000" y="2194560"/>
-            <a:ext cx="2926080" cy="3749039"/>
+            <a:off x="6400800" y="5120640"/>
+            <a:ext cx="4846320" cy="1005840"/>
           </a:xfrm>
           <a:prstGeom prst="rect">
             <a:avLst/>
@@ -4110,113 +4133,14 @@
           <a:lstStyle/>
           <a:p>
             <a:pPr>
-              <a:defRPr sz="1050">
+              <a:defRPr sz="1000">
                 <a:solidFill>
                   <a:srgbClr val="F8FAFC"/>
                 </a:solidFill>
               </a:defRPr>
             </a:pPr>
             <a:r>
-              <a:t>Zero-Downtime Defense:</a:t>
-            </a:r>
-            <a:br/>
-            <a:br/>
-            <a:r>
-              <a:t>Free cloud services (Render, Supabase) may experience a 30-50 second cold-start spin-up.</a:t>
-            </a:r>
-            <a:br/>
-            <a:br/>
-            <a:r>
-              <a:t>HARMONY Dual-Store Innovation:</a:t>
-            </a:r>
-            <a:br/>
-            <a:r>
-              <a:t>The frontend React client checks API reachability. If the remote API is warming up, the UI automatically falls back to an authenticated synchronized memory store.</a:t>
-            </a:r>
-            <a:br/>
-            <a:br/>
-            <a:r>
-              <a:t>Result: 0% chance of presentation crash or blank page during panel inspection!</a:t>
-            </a:r>
-          </a:p>
-        </p:txBody>
-      </p:sp>
-      <p:sp>
-        <p:nvSpPr>
-          <p:cNvPr id="12" name="Rounded Rectangle 11"/>
-          <p:cNvSpPr/>
-          <p:nvPr/>
-        </p:nvSpPr>
-        <p:spPr>
-          <a:xfrm>
-            <a:off x="8046720" y="1645920"/>
-            <a:ext cx="3383280" cy="4480560"/>
-          </a:xfrm>
-          <a:prstGeom prst="roundRect">
-            <a:avLst/>
-          </a:prstGeom>
-          <a:solidFill>
-            <a:srgbClr val="1E293B"/>
-          </a:solidFill>
-          <a:ln w="12700">
-            <a:solidFill>
-              <a:srgbClr val="334155"/>
-            </a:solidFill>
-          </a:ln>
-        </p:spPr>
-        <p:style>
-          <a:lnRef idx="1">
-            <a:schemeClr val="accent1"/>
-          </a:lnRef>
-          <a:fillRef idx="3">
-            <a:schemeClr val="accent1"/>
-          </a:fillRef>
-          <a:effectRef idx="2">
-            <a:schemeClr val="accent1"/>
-          </a:effectRef>
-          <a:fontRef idx="minor">
-            <a:schemeClr val="lt1"/>
-          </a:fontRef>
-        </p:style>
-        <p:txBody>
-          <a:bodyPr rtlCol="0" anchor="ctr"/>
-          <a:lstStyle/>
-          <a:p>
-            <a:pPr algn="ctr"/>
-          </a:p>
-        </p:txBody>
-      </p:sp>
-      <p:sp>
-        <p:nvSpPr>
-          <p:cNvPr id="13" name="TextBox 12"/>
-          <p:cNvSpPr txBox="1"/>
-          <p:nvPr/>
-        </p:nvSpPr>
-        <p:spPr>
-          <a:xfrm>
-            <a:off x="8229600" y="1783080"/>
-            <a:ext cx="3017520" cy="365760"/>
-          </a:xfrm>
-          <a:prstGeom prst="rect">
-            <a:avLst/>
-          </a:prstGeom>
-          <a:noFill/>
-        </p:spPr>
-        <p:txBody>
-          <a:bodyPr wrap="square" lIns="0" tIns="0" rIns="0" bIns="0">
-            <a:spAutoFit/>
-          </a:bodyPr>
-          <a:lstStyle/>
-          <a:p>
-            <a:pPr>
-              <a:defRPr sz="1400" b="1">
-                <a:solidFill>
-                  <a:srgbClr val="06B6D4"/>
-                </a:solidFill>
-              </a:defRPr>
-            </a:pPr>
-            <a:r>
-              <a:t>VIVA DEFENSE READINESS</a:t>
+              <a:t>Real-time Net Balance card, Effort Leaderboard, Pending vs Completed chores, and recent shared bills with one-click actions.</a:t>
             </a:r>
           </a:p>
         </p:txBody>
@@ -4224,77 +4148,6 @@
       <p:sp>
         <p:nvSpPr>
           <p:cNvPr id="14" name="TextBox 13"/>
-          <p:cNvSpPr txBox="1"/>
-          <p:nvPr/>
-        </p:nvSpPr>
-        <p:spPr>
-          <a:xfrm>
-            <a:off x="8229600" y="2194560"/>
-            <a:ext cx="3017520" cy="3749039"/>
-          </a:xfrm>
-          <a:prstGeom prst="rect">
-            <a:avLst/>
-          </a:prstGeom>
-          <a:noFill/>
-        </p:spPr>
-        <p:txBody>
-          <a:bodyPr wrap="square">
-            <a:spAutoFit/>
-          </a:bodyPr>
-          <a:lstStyle/>
-          <a:p>
-            <a:pPr>
-              <a:defRPr sz="1050">
-                <a:solidFill>
-                  <a:srgbClr val="F8FAFC"/>
-                </a:solidFill>
-              </a:defRPr>
-            </a:pPr>
-            <a:r>
-              <a:t>Key Concepts for Panel 2:</a:t>
-            </a:r>
-            <a:br/>
-            <a:br/>
-            <a:r>
-              <a:t>• 3-Tier Architecture:</a:t>
-            </a:r>
-            <a:br/>
-            <a:r>
-              <a:t>  Clear decoupling between React client, Express API, and SQL DB.</a:t>
-            </a:r>
-            <a:br/>
-            <a:br/>
-            <a:r>
-              <a:t>• RESTful Methods:</a:t>
-            </a:r>
-            <a:br/>
-            <a:r>
-              <a:t>  GET (retrieve), POST (create), PUT (update state), DELETE (remove).</a:t>
-            </a:r>
-            <a:br/>
-            <a:br/>
-            <a:r>
-              <a:t>• Normalization:</a:t>
-            </a:r>
-            <a:br/>
-            <a:r>
-              <a:t>  Eliminating insertion, deletion, and update anomalies via 3NF tables.</a:t>
-            </a:r>
-            <a:br/>
-            <a:br/>
-            <a:r>
-              <a:t>• State Management:</a:t>
-            </a:r>
-            <a:br/>
-            <a:r>
-              <a:t>  React Context API + Hooks for predictable frontend data flow.</a:t>
-            </a:r>
-          </a:p>
-        </p:txBody>
-      </p:sp>
-      <p:sp>
-        <p:nvSpPr>
-          <p:cNvPr id="15" name="TextBox 14"/>
           <p:cNvSpPr txBox="1"/>
           <p:nvPr/>
         </p:nvSpPr>
@@ -4322,7 +4175,7 @@
               </a:defRPr>
             </a:pPr>
             <a:r>
-              <a:t>HARMONY | Candidate: Lakshya Shukla (240919106121) | Guide: Mr. Nihal Kumar | IMS Noida (Panel 2 - Room DG4) | Slide 10 of 12</a:t>
+              <a:t>HARMONY | Candidate: Lakshya Shukla (240919106121) | Guide: Mr. Nihal Kumar | IMS Noida (Panel 2 - Room DG4) | Slide 10 of 14</a:t>
             </a:r>
           </a:p>
         </p:txBody>
@@ -4446,14 +4299,14 @@
           <a:lstStyle/>
           <a:p>
             <a:pPr>
-              <a:defRPr sz="2400" b="1">
+              <a:defRPr sz="2300" b="1">
                 <a:solidFill>
                   <a:srgbClr val="F8FAFC"/>
                 </a:solidFill>
               </a:defRPr>
             </a:pPr>
             <a:r>
-              <a:t>Cloud Deployment Topology &amp; Mandatory Live Links</a:t>
+              <a:t>Role-Based Access Control (RBAC) &amp; Governance</a:t>
             </a:r>
           </a:p>
         </p:txBody>
@@ -4501,16 +4354,40 @@
           </a:p>
         </p:txBody>
       </p:sp>
-      <p:sp>
-        <p:nvSpPr>
-          <p:cNvPr id="6" name="Rounded Rectangle 5"/>
+      <p:pic>
+        <p:nvPicPr>
+          <p:cNvPr id="6" name="Picture 5" descr="ui_admin.png"/>
+          <p:cNvPicPr>
+            <a:picLocks noChangeAspect="1"/>
+          </p:cNvPicPr>
+          <p:nvPr/>
+        </p:nvPicPr>
+        <p:blipFill>
+          <a:blip r:embed="rId2"/>
+          <a:stretch>
+            <a:fillRect/>
+          </a:stretch>
+        </p:blipFill>
+        <p:spPr>
+          <a:xfrm>
+            <a:off x="731520" y="1645920"/>
+            <a:ext cx="5486400" cy="4480560"/>
+          </a:xfrm>
+          <a:prstGeom prst="rect">
+            <a:avLst/>
+          </a:prstGeom>
+        </p:spPr>
+      </p:pic>
+      <p:sp>
+        <p:nvSpPr>
+          <p:cNvPr id="7" name="Rounded Rectangle 6"/>
           <p:cNvSpPr/>
           <p:nvPr/>
         </p:nvSpPr>
         <p:spPr>
           <a:xfrm>
-            <a:off x="731520" y="1645920"/>
-            <a:ext cx="10728655" cy="4480560"/>
+            <a:off x="6492240" y="1645920"/>
+            <a:ext cx="4937760" cy="4480560"/>
           </a:xfrm>
           <a:prstGeom prst="roundRect">
             <a:avLst/>
@@ -4520,7 +4397,7 @@
           </a:solidFill>
           <a:ln w="12700">
             <a:solidFill>
-              <a:srgbClr val="10B981"/>
+              <a:srgbClr val="334155"/>
             </a:solidFill>
           </a:ln>
         </p:spPr>
@@ -4548,14 +4425,14 @@
       </p:sp>
       <p:sp>
         <p:nvSpPr>
-          <p:cNvPr id="7" name="TextBox 6"/>
+          <p:cNvPr id="8" name="TextBox 7"/>
           <p:cNvSpPr txBox="1"/>
           <p:nvPr/>
         </p:nvSpPr>
         <p:spPr>
           <a:xfrm>
-            <a:off x="914400" y="1783080"/>
-            <a:ext cx="10362895" cy="365760"/>
+            <a:off x="6675120" y="1783080"/>
+            <a:ext cx="4572000" cy="365760"/>
           </a:xfrm>
           <a:prstGeom prst="rect">
             <a:avLst/>
@@ -4569,28 +4446,28 @@
           <a:lstStyle/>
           <a:p>
             <a:pPr>
-              <a:defRPr sz="1400" b="1">
+              <a:defRPr sz="1300" b="1">
                 <a:solidFill>
                   <a:srgbClr val="06B6D4"/>
                 </a:solidFill>
               </a:defRPr>
             </a:pPr>
             <a:r>
-              <a:t>PRODUCTION CLOUD DEPLOYMENT TOPOLOGY</a:t>
-            </a:r>
-          </a:p>
-        </p:txBody>
-      </p:sp>
-      <p:sp>
-        <p:nvSpPr>
-          <p:cNvPr id="8" name="TextBox 7"/>
+              <a:t>GOVERNANCE &amp; PERMISSIONS</a:t>
+            </a:r>
+          </a:p>
+        </p:txBody>
+      </p:sp>
+      <p:sp>
+        <p:nvSpPr>
+          <p:cNvPr id="9" name="TextBox 8"/>
           <p:cNvSpPr txBox="1"/>
           <p:nvPr/>
         </p:nvSpPr>
         <p:spPr>
           <a:xfrm>
-            <a:off x="1005840" y="2194560"/>
-            <a:ext cx="10149840" cy="3749039"/>
+            <a:off x="6675120" y="2194560"/>
+            <a:ext cx="4572000" cy="3749039"/>
           </a:xfrm>
           <a:prstGeom prst="rect">
             <a:avLst/>
@@ -4604,112 +4481,65 @@
           <a:lstStyle/>
           <a:p>
             <a:pPr>
-              <a:defRPr sz="1300" b="1">
-                <a:solidFill>
-                  <a:srgbClr val="10B981"/>
+              <a:defRPr sz="1050">
+                <a:solidFill>
+                  <a:srgbClr val="F8FAFC"/>
                 </a:solidFill>
               </a:defRPr>
             </a:pPr>
             <a:r>
-              <a:t>Deployment Architecture Breakdown (Mandated by Department for Final Presentation):</a:t>
-            </a:r>
-          </a:p>
-          <a:p>
-            <a:r>
-              <a:rPr sz="1200" b="1">
-                <a:solidFill>
-                  <a:srgbClr val="06B6D4"/>
-                </a:solidFill>
-              </a:rPr>
-              <a:t>
-1. Frontend SPA Deployment: Vercel Edge Network
-</a:t>
-            </a:r>
-            <a:r>
-              <a:rPr sz="1100">
-                <a:solidFill>
-                  <a:srgbClr val="F8FAFC"/>
-                </a:solidFill>
-              </a:rPr>
-              <a:t>   • Built with Vite, bundled to /dist, distributed globally across CDN edge points.
-   • Direct Clickable Live URL: </a:t>
-            </a:r>
-            <a:r>
-              <a:rPr sz="1200" b="1" u="sng">
-                <a:solidFill>
-                  <a:srgbClr val="06B6D4"/>
-                </a:solidFill>
-                <a:hlinkClick r:id="rId2"/>
-              </a:rPr>
-              <a:t>https://harmony-household.vercel.app
-</a:t>
-            </a:r>
-          </a:p>
-          <a:p>
-            <a:r>
-              <a:rPr sz="1200" b="1">
-                <a:solidFill>
-                  <a:srgbClr val="8B5CF6"/>
-                </a:solidFill>
-              </a:rPr>
-              <a:t>2. Backend API Deployment: Render Web Service
-</a:t>
-            </a:r>
-            <a:r>
-              <a:rPr sz="1100">
-                <a:solidFill>
-                  <a:srgbClr val="F8FAFC"/>
-                </a:solidFill>
-              </a:rPr>
-              <a:t>   • Node.js/Express environment with automatic health checks (/api/health).
-   • Direct API Endpoint: </a:t>
-            </a:r>
-            <a:r>
-              <a:rPr sz="1200" b="1" u="sng">
-                <a:solidFill>
-                  <a:srgbClr val="06B6D4"/>
-                </a:solidFill>
-                <a:hlinkClick r:id="rId3"/>
-              </a:rPr>
-              <a:t>https://harmony-api.onrender.com/api/health
-</a:t>
-            </a:r>
-          </a:p>
-          <a:p>
-            <a:r>
-              <a:rPr sz="1200" b="1">
-                <a:solidFill>
-                  <a:srgbClr val="F59E0B"/>
-                </a:solidFill>
-              </a:rPr>
-              <a:t>3. Version Control &amp; Source Code Repository: GitHub
-</a:t>
-            </a:r>
-            <a:r>
-              <a:rPr sz="1100">
-                <a:solidFill>
-                  <a:srgbClr val="F8FAFC"/>
-                </a:solidFill>
-              </a:rPr>
-              <a:t>   • Continuous Integration from main branch with verified commit history.
-   • Repository URL: </a:t>
-            </a:r>
-            <a:r>
-              <a:rPr sz="1200" b="1" u="sng">
-                <a:solidFill>
-                  <a:srgbClr val="06B6D4"/>
-                </a:solidFill>
-                <a:hlinkClick r:id="rId4"/>
-              </a:rPr>
-              <a:t>https://github.com/lakshya212/HARMONY
-</a:t>
-            </a:r>
-          </a:p>
-        </p:txBody>
-      </p:sp>
-      <p:sp>
-        <p:nvSpPr>
-          <p:cNvPr id="9" name="TextBox 8"/>
+              <a:t>Role Hierarchy:</a:t>
+            </a:r>
+            <a:br/>
+            <a:br/>
+            <a:r>
+              <a:t>• Household Admin (Primary Householder):</a:t>
+            </a:r>
+            <a:br/>
+            <a:r>
+              <a:t>  Can create households, issue invite codes, assign chores, remove flatmates, and settle dispute adjustments.</a:t>
+            </a:r>
+            <a:br/>
+            <a:br/>
+            <a:r>
+              <a:t>• Household Member:</a:t>
+            </a:r>
+            <a:br/>
+            <a:r>
+              <a:t>  Can view dashboard, log new bills, claim/complete chores, and inspect net balances.</a:t>
+            </a:r>
+            <a:br/>
+            <a:br/>
+            <a:r>
+              <a:t>• System SuperAdmin:</a:t>
+            </a:r>
+            <a:br/>
+            <a:r>
+              <a:t>  Full audit visibility across all households, system health, and database purge tools.</a:t>
+            </a:r>
+            <a:br/>
+            <a:br/>
+            <a:r>
+              <a:t>Security Protections:</a:t>
+            </a:r>
+            <a:br/>
+            <a:r>
+              <a:t>• Input sanitization against XSS and SQL injection.</a:t>
+            </a:r>
+            <a:br/>
+            <a:r>
+              <a:t>• JWT / Bearer Token authorization verification.</a:t>
+            </a:r>
+            <a:br/>
+            <a:r>
+              <a:t>• Strict household tenancy isolation (members cannot view expenses of other households).</a:t>
+            </a:r>
+          </a:p>
+        </p:txBody>
+      </p:sp>
+      <p:sp>
+        <p:nvSpPr>
+          <p:cNvPr id="10" name="TextBox 9"/>
           <p:cNvSpPr txBox="1"/>
           <p:nvPr/>
         </p:nvSpPr>
@@ -4737,7 +4567,7 @@
               </a:defRPr>
             </a:pPr>
             <a:r>
-              <a:t>HARMONY | Candidate: Lakshya Shukla (240919106121) | Guide: Mr. Nihal Kumar | IMS Noida (Panel 2 - Room DG4) | Slide 11 of 12</a:t>
+              <a:t>HARMONY | Candidate: Lakshya Shukla (240919106121) | Guide: Mr. Nihal Kumar | IMS Noida (Panel 2 - Room DG4) | Slide 11 of 14</a:t>
             </a:r>
           </a:p>
         </p:txBody>
@@ -4833,7 +4663,7 @@
               </a:defRPr>
             </a:pPr>
             <a:r>
-              <a:t>MINOR PROJECT STATUS: 100% COMPLETE &amp; DEPLOYED</a:t>
+              <a:t>BCA-508 MINOR PROJECT FINAL PRESENTATION</a:t>
             </a:r>
           </a:p>
         </p:txBody>
@@ -4861,14 +4691,14 @@
           <a:lstStyle/>
           <a:p>
             <a:pPr>
-              <a:defRPr sz="2400" b="1">
+              <a:defRPr sz="2300" b="1">
                 <a:solidFill>
                   <a:srgbClr val="F8FAFC"/>
                 </a:solidFill>
               </a:defRPr>
             </a:pPr>
             <a:r>
-              <a:t>Final Presentation Summary &amp; Viva Defense</a:t>
+              <a:t>Quality Assurance, Testing &amp; Presentation Defense</a:t>
             </a:r>
           </a:p>
         </p:txBody>
@@ -4925,7 +4755,7 @@
         <p:spPr>
           <a:xfrm>
             <a:off x="731520" y="1645920"/>
-            <a:ext cx="5120640" cy="4480560"/>
+            <a:ext cx="3291840" cy="4480560"/>
           </a:xfrm>
           <a:prstGeom prst="roundRect">
             <a:avLst/>
@@ -4970,7 +4800,7 @@
         <p:spPr>
           <a:xfrm>
             <a:off x="914400" y="1783080"/>
-            <a:ext cx="4754880" cy="365760"/>
+            <a:ext cx="2926080" cy="365760"/>
           </a:xfrm>
           <a:prstGeom prst="rect">
             <a:avLst/>
@@ -4984,14 +4814,14 @@
           <a:lstStyle/>
           <a:p>
             <a:pPr>
-              <a:defRPr sz="1400" b="1">
+              <a:defRPr sz="1300" b="1">
                 <a:solidFill>
                   <a:srgbClr val="06B6D4"/>
                 </a:solidFill>
               </a:defRPr>
             </a:pPr>
             <a:r>
-              <a:t>FINAL DELIVERABLES READY</a:t>
+              <a:t>TEST SUITE EXECUTION</a:t>
             </a:r>
           </a:p>
         </p:txBody>
@@ -5005,7 +4835,7 @@
         <p:spPr>
           <a:xfrm>
             <a:off x="914400" y="2194560"/>
-            <a:ext cx="4754880" cy="3749039"/>
+            <a:ext cx="2926080" cy="3749039"/>
           </a:xfrm>
           <a:prstGeom prst="rect">
             <a:avLst/>
@@ -5019,50 +4849,50 @@
           <a:lstStyle/>
           <a:p>
             <a:pPr>
-              <a:defRPr sz="1100">
+              <a:defRPr sz="1050">
                 <a:solidFill>
                   <a:srgbClr val="F8FAFC"/>
                 </a:solidFill>
               </a:defRPr>
             </a:pPr>
             <a:r>
-              <a:t>Mandatory Submissions for Panel 2:</a:t>
-            </a:r>
-            <a:br/>
-            <a:br/>
-            <a:r>
-              <a:t>[X] PDF of Project Along with Code:</a:t>
-            </a:r>
-            <a:br/>
-            <a:r>
-              <a:t>    Comprehensive documentation with Cannock Pvt Ltd certificate, DFDs, ERD, and Section 12 full source code appendix.</a:t>
-            </a:r>
-            <a:br/>
-            <a:br/>
-            <a:r>
-              <a:t>[X] Project Deployment Link:</a:t>
-            </a:r>
-            <a:br/>
-            <a:r>
-              <a:t>    Production web app live on Vercel with resilient client fallback.</a:t>
-            </a:r>
-            <a:br/>
-            <a:br/>
-            <a:r>
-              <a:t>[X] PPT for Presentation (Mandatory):</a:t>
-            </a:r>
-            <a:br/>
-            <a:r>
-              <a:t>    12-slide comprehensive presentation with live clickable links.</a:t>
-            </a:r>
-            <a:br/>
-            <a:br/>
-            <a:r>
-              <a:t>[X] GitHub Source Code Repository:</a:t>
-            </a:r>
-            <a:br/>
-            <a:r>
-              <a:t>    Publicly accessible at github.com/lakshya212/HARMONY.</a:t>
+              <a:t>Verified Test Cases:</a:t>
+            </a:r>
+            <a:br/>
+            <a:br/>
+            <a:r>
+              <a:t>• Auth Verification:</a:t>
+            </a:r>
+            <a:br/>
+            <a:r>
+              <a:t>  Valid login, wrong credentials, session token persistence.</a:t>
+            </a:r>
+            <a:br/>
+            <a:br/>
+            <a:r>
+              <a:t>• Ledger Verification:</a:t>
+            </a:r>
+            <a:br/>
+            <a:r>
+              <a:t>  Zero-sum test: Sum of all net balances strictly equals 0.</a:t>
+            </a:r>
+            <a:br/>
+            <a:br/>
+            <a:r>
+              <a:t>• Task Life Cycle:</a:t>
+            </a:r>
+            <a:br/>
+            <a:r>
+              <a:t>  Pending -&gt; In-Progress -&gt; Completed -&gt; Point Increment.</a:t>
+            </a:r>
+            <a:br/>
+            <a:br/>
+            <a:r>
+              <a:t>• Edge-Case Handling:</a:t>
+            </a:r>
+            <a:br/>
+            <a:r>
+              <a:t>  Zero-amount expense rejected; duplicate member prevention.</a:t>
             </a:r>
           </a:p>
         </p:txBody>
@@ -5075,8 +4905,502 @@
         </p:nvSpPr>
         <p:spPr>
           <a:xfrm>
-            <a:off x="6217920" y="1645920"/>
-            <a:ext cx="5212080" cy="4480560"/>
+            <a:off x="4389120" y="1645920"/>
+            <a:ext cx="3291840" cy="4480560"/>
+          </a:xfrm>
+          <a:prstGeom prst="roundRect">
+            <a:avLst/>
+          </a:prstGeom>
+          <a:solidFill>
+            <a:srgbClr val="1E293B"/>
+          </a:solidFill>
+          <a:ln w="12700">
+            <a:solidFill>
+              <a:srgbClr val="334155"/>
+            </a:solidFill>
+          </a:ln>
+        </p:spPr>
+        <p:style>
+          <a:lnRef idx="1">
+            <a:schemeClr val="accent1"/>
+          </a:lnRef>
+          <a:fillRef idx="3">
+            <a:schemeClr val="accent1"/>
+          </a:fillRef>
+          <a:effectRef idx="2">
+            <a:schemeClr val="accent1"/>
+          </a:effectRef>
+          <a:fontRef idx="minor">
+            <a:schemeClr val="lt1"/>
+          </a:fontRef>
+        </p:style>
+        <p:txBody>
+          <a:bodyPr rtlCol="0" anchor="ctr"/>
+          <a:lstStyle/>
+          <a:p>
+            <a:pPr algn="ctr"/>
+          </a:p>
+        </p:txBody>
+      </p:sp>
+      <p:sp>
+        <p:nvSpPr>
+          <p:cNvPr id="10" name="TextBox 9"/>
+          <p:cNvSpPr txBox="1"/>
+          <p:nvPr/>
+        </p:nvSpPr>
+        <p:spPr>
+          <a:xfrm>
+            <a:off x="4572000" y="1783080"/>
+            <a:ext cx="2926080" cy="365760"/>
+          </a:xfrm>
+          <a:prstGeom prst="rect">
+            <a:avLst/>
+          </a:prstGeom>
+          <a:noFill/>
+        </p:spPr>
+        <p:txBody>
+          <a:bodyPr wrap="square" lIns="0" tIns="0" rIns="0" bIns="0">
+            <a:spAutoFit/>
+          </a:bodyPr>
+          <a:lstStyle/>
+          <a:p>
+            <a:pPr>
+              <a:defRPr sz="1300" b="1">
+                <a:solidFill>
+                  <a:srgbClr val="06B6D4"/>
+                </a:solidFill>
+              </a:defRPr>
+            </a:pPr>
+            <a:r>
+              <a:t>OFFLINE RESILIENCE</a:t>
+            </a:r>
+          </a:p>
+        </p:txBody>
+      </p:sp>
+      <p:sp>
+        <p:nvSpPr>
+          <p:cNvPr id="11" name="TextBox 10"/>
+          <p:cNvSpPr txBox="1"/>
+          <p:nvPr/>
+        </p:nvSpPr>
+        <p:spPr>
+          <a:xfrm>
+            <a:off x="4572000" y="2194560"/>
+            <a:ext cx="2926080" cy="3749039"/>
+          </a:xfrm>
+          <a:prstGeom prst="rect">
+            <a:avLst/>
+          </a:prstGeom>
+          <a:noFill/>
+        </p:spPr>
+        <p:txBody>
+          <a:bodyPr wrap="square">
+            <a:spAutoFit/>
+          </a:bodyPr>
+          <a:lstStyle/>
+          <a:p>
+            <a:pPr>
+              <a:defRPr sz="1050">
+                <a:solidFill>
+                  <a:srgbClr val="F8FAFC"/>
+                </a:solidFill>
+              </a:defRPr>
+            </a:pPr>
+            <a:r>
+              <a:t>Zero-Downtime Defense:</a:t>
+            </a:r>
+            <a:br/>
+            <a:br/>
+            <a:r>
+              <a:t>Free cloud services (Render, Supabase) may experience a 30-50 second cold-start spin-up.</a:t>
+            </a:r>
+            <a:br/>
+            <a:br/>
+            <a:r>
+              <a:t>HARMONY Dual-Store Innovation:</a:t>
+            </a:r>
+            <a:br/>
+            <a:r>
+              <a:t>The frontend React client checks API reachability. If the remote API is warming up, the UI automatically falls back to an authenticated synchronized memory store.</a:t>
+            </a:r>
+            <a:br/>
+            <a:br/>
+            <a:r>
+              <a:t>Result: 0% chance of presentation crash or blank page during panel inspection!</a:t>
+            </a:r>
+          </a:p>
+        </p:txBody>
+      </p:sp>
+      <p:sp>
+        <p:nvSpPr>
+          <p:cNvPr id="12" name="Rounded Rectangle 11"/>
+          <p:cNvSpPr/>
+          <p:nvPr/>
+        </p:nvSpPr>
+        <p:spPr>
+          <a:xfrm>
+            <a:off x="8046720" y="1645920"/>
+            <a:ext cx="3383280" cy="4480560"/>
+          </a:xfrm>
+          <a:prstGeom prst="roundRect">
+            <a:avLst/>
+          </a:prstGeom>
+          <a:solidFill>
+            <a:srgbClr val="1E293B"/>
+          </a:solidFill>
+          <a:ln w="12700">
+            <a:solidFill>
+              <a:srgbClr val="334155"/>
+            </a:solidFill>
+          </a:ln>
+        </p:spPr>
+        <p:style>
+          <a:lnRef idx="1">
+            <a:schemeClr val="accent1"/>
+          </a:lnRef>
+          <a:fillRef idx="3">
+            <a:schemeClr val="accent1"/>
+          </a:fillRef>
+          <a:effectRef idx="2">
+            <a:schemeClr val="accent1"/>
+          </a:effectRef>
+          <a:fontRef idx="minor">
+            <a:schemeClr val="lt1"/>
+          </a:fontRef>
+        </p:style>
+        <p:txBody>
+          <a:bodyPr rtlCol="0" anchor="ctr"/>
+          <a:lstStyle/>
+          <a:p>
+            <a:pPr algn="ctr"/>
+          </a:p>
+        </p:txBody>
+      </p:sp>
+      <p:sp>
+        <p:nvSpPr>
+          <p:cNvPr id="13" name="TextBox 12"/>
+          <p:cNvSpPr txBox="1"/>
+          <p:nvPr/>
+        </p:nvSpPr>
+        <p:spPr>
+          <a:xfrm>
+            <a:off x="8229600" y="1783080"/>
+            <a:ext cx="3017520" cy="365760"/>
+          </a:xfrm>
+          <a:prstGeom prst="rect">
+            <a:avLst/>
+          </a:prstGeom>
+          <a:noFill/>
+        </p:spPr>
+        <p:txBody>
+          <a:bodyPr wrap="square" lIns="0" tIns="0" rIns="0" bIns="0">
+            <a:spAutoFit/>
+          </a:bodyPr>
+          <a:lstStyle/>
+          <a:p>
+            <a:pPr>
+              <a:defRPr sz="1300" b="1">
+                <a:solidFill>
+                  <a:srgbClr val="06B6D4"/>
+                </a:solidFill>
+              </a:defRPr>
+            </a:pPr>
+            <a:r>
+              <a:t>VIVA DEFENSE READINESS</a:t>
+            </a:r>
+          </a:p>
+        </p:txBody>
+      </p:sp>
+      <p:sp>
+        <p:nvSpPr>
+          <p:cNvPr id="14" name="TextBox 13"/>
+          <p:cNvSpPr txBox="1"/>
+          <p:nvPr/>
+        </p:nvSpPr>
+        <p:spPr>
+          <a:xfrm>
+            <a:off x="8229600" y="2194560"/>
+            <a:ext cx="3017520" cy="3749039"/>
+          </a:xfrm>
+          <a:prstGeom prst="rect">
+            <a:avLst/>
+          </a:prstGeom>
+          <a:noFill/>
+        </p:spPr>
+        <p:txBody>
+          <a:bodyPr wrap="square">
+            <a:spAutoFit/>
+          </a:bodyPr>
+          <a:lstStyle/>
+          <a:p>
+            <a:pPr>
+              <a:defRPr sz="1050">
+                <a:solidFill>
+                  <a:srgbClr val="F8FAFC"/>
+                </a:solidFill>
+              </a:defRPr>
+            </a:pPr>
+            <a:r>
+              <a:t>Key Concepts for Panel 2:</a:t>
+            </a:r>
+            <a:br/>
+            <a:br/>
+            <a:r>
+              <a:t>• 3-Tier Architecture:</a:t>
+            </a:r>
+            <a:br/>
+            <a:r>
+              <a:t>  Clear decoupling between React client, Express API, and SQL DB.</a:t>
+            </a:r>
+            <a:br/>
+            <a:br/>
+            <a:r>
+              <a:t>• RESTful Methods:</a:t>
+            </a:r>
+            <a:br/>
+            <a:r>
+              <a:t>  GET (retrieve), POST (create), PUT (update state), DELETE (remove).</a:t>
+            </a:r>
+            <a:br/>
+            <a:br/>
+            <a:r>
+              <a:t>• Normalization:</a:t>
+            </a:r>
+            <a:br/>
+            <a:r>
+              <a:t>  Eliminating insertion, deletion, and update anomalies via 3NF tables.</a:t>
+            </a:r>
+            <a:br/>
+            <a:br/>
+            <a:r>
+              <a:t>• State Management:</a:t>
+            </a:r>
+            <a:br/>
+            <a:r>
+              <a:t>  React Context API + Hooks for predictable frontend data flow.</a:t>
+            </a:r>
+          </a:p>
+        </p:txBody>
+      </p:sp>
+      <p:sp>
+        <p:nvSpPr>
+          <p:cNvPr id="15" name="TextBox 14"/>
+          <p:cNvSpPr txBox="1"/>
+          <p:nvPr/>
+        </p:nvSpPr>
+        <p:spPr>
+          <a:xfrm>
+            <a:off x="731520" y="6400800"/>
+            <a:ext cx="10728655" cy="320040"/>
+          </a:xfrm>
+          <a:prstGeom prst="rect">
+            <a:avLst/>
+          </a:prstGeom>
+          <a:noFill/>
+        </p:spPr>
+        <p:txBody>
+          <a:bodyPr wrap="none" lIns="0" tIns="0" rIns="0" bIns="0">
+            <a:spAutoFit/>
+          </a:bodyPr>
+          <a:lstStyle/>
+          <a:p>
+            <a:pPr>
+              <a:defRPr sz="900">
+                <a:solidFill>
+                  <a:srgbClr val="94A3B8"/>
+                </a:solidFill>
+              </a:defRPr>
+            </a:pPr>
+            <a:r>
+              <a:t>HARMONY | Candidate: Lakshya Shukla (240919106121) | Guide: Mr. Nihal Kumar | IMS Noida (Panel 2 - Room DG4) | Slide 12 of 14</a:t>
+            </a:r>
+          </a:p>
+        </p:txBody>
+      </p:sp>
+    </p:spTree>
+  </p:cSld>
+  <p:clrMapOvr>
+    <a:masterClrMapping/>
+  </p:clrMapOvr>
+</p:sld>
+</file>
+
+<file path=ppt/slides/slide13.xml><?xml version="1.0" encoding="utf-8"?>
+<p:sld xmlns:a="http://schemas.openxmlformats.org/drawingml/2006/main" xmlns:p="http://schemas.openxmlformats.org/presentationml/2006/main" xmlns:r="http://schemas.openxmlformats.org/officeDocument/2006/relationships">
+  <p:cSld>
+    <p:spTree>
+      <p:nvGrpSpPr>
+        <p:cNvPr id="1" name=""/>
+        <p:cNvGrpSpPr/>
+        <p:nvPr/>
+      </p:nvGrpSpPr>
+      <p:grpSpPr/>
+      <p:sp>
+        <p:nvSpPr>
+          <p:cNvPr id="2" name="Rectangle 1"/>
+          <p:cNvSpPr/>
+          <p:nvPr/>
+        </p:nvSpPr>
+        <p:spPr>
+          <a:xfrm>
+            <a:off x="0" y="0"/>
+            <a:ext cx="12191695" cy="6858000"/>
+          </a:xfrm>
+          <a:prstGeom prst="rect">
+            <a:avLst/>
+          </a:prstGeom>
+          <a:solidFill>
+            <a:srgbClr val="0F172A"/>
+          </a:solidFill>
+          <a:ln>
+            <a:noFill/>
+          </a:ln>
+        </p:spPr>
+        <p:style>
+          <a:lnRef idx="1">
+            <a:schemeClr val="accent1"/>
+          </a:lnRef>
+          <a:fillRef idx="3">
+            <a:schemeClr val="accent1"/>
+          </a:fillRef>
+          <a:effectRef idx="2">
+            <a:schemeClr val="accent1"/>
+          </a:effectRef>
+          <a:fontRef idx="minor">
+            <a:schemeClr val="lt1"/>
+          </a:fontRef>
+        </p:style>
+        <p:txBody>
+          <a:bodyPr rtlCol="0" anchor="ctr"/>
+          <a:lstStyle/>
+          <a:p>
+            <a:pPr algn="ctr"/>
+          </a:p>
+        </p:txBody>
+      </p:sp>
+      <p:sp>
+        <p:nvSpPr>
+          <p:cNvPr id="3" name="TextBox 2"/>
+          <p:cNvSpPr txBox="1"/>
+          <p:nvPr/>
+        </p:nvSpPr>
+        <p:spPr>
+          <a:xfrm>
+            <a:off x="731520" y="365760"/>
+            <a:ext cx="10698480" cy="365760"/>
+          </a:xfrm>
+          <a:prstGeom prst="rect">
+            <a:avLst/>
+          </a:prstGeom>
+          <a:noFill/>
+        </p:spPr>
+        <p:txBody>
+          <a:bodyPr wrap="square" lIns="0" tIns="0" rIns="0" bIns="0">
+            <a:spAutoFit/>
+          </a:bodyPr>
+          <a:lstStyle/>
+          <a:p>
+            <a:pPr>
+              <a:defRPr sz="1100" b="1">
+                <a:solidFill>
+                  <a:srgbClr val="10B981"/>
+                </a:solidFill>
+              </a:defRPr>
+            </a:pPr>
+            <a:r>
+              <a:t>BCA-508 MINOR PROJECT FINAL PRESENTATION</a:t>
+            </a:r>
+          </a:p>
+        </p:txBody>
+      </p:sp>
+      <p:sp>
+        <p:nvSpPr>
+          <p:cNvPr id="4" name="TextBox 3"/>
+          <p:cNvSpPr txBox="1"/>
+          <p:nvPr/>
+        </p:nvSpPr>
+        <p:spPr>
+          <a:xfrm>
+            <a:off x="731520" y="685800"/>
+            <a:ext cx="10698480" cy="640080"/>
+          </a:xfrm>
+          <a:prstGeom prst="rect">
+            <a:avLst/>
+          </a:prstGeom>
+          <a:noFill/>
+        </p:spPr>
+        <p:txBody>
+          <a:bodyPr wrap="square" lIns="0" tIns="0" rIns="0" bIns="0">
+            <a:spAutoFit/>
+          </a:bodyPr>
+          <a:lstStyle/>
+          <a:p>
+            <a:pPr>
+              <a:defRPr sz="2300" b="1">
+                <a:solidFill>
+                  <a:srgbClr val="F8FAFC"/>
+                </a:solidFill>
+              </a:defRPr>
+            </a:pPr>
+            <a:r>
+              <a:t>Multi-Cloud Deployment Topology &amp; Mandatory Live Links</a:t>
+            </a:r>
+          </a:p>
+        </p:txBody>
+      </p:sp>
+      <p:sp>
+        <p:nvSpPr>
+          <p:cNvPr id="5" name="Rectangle 4"/>
+          <p:cNvSpPr/>
+          <p:nvPr/>
+        </p:nvSpPr>
+        <p:spPr>
+          <a:xfrm>
+            <a:off x="731520" y="1371600"/>
+            <a:ext cx="10728655" cy="18288"/>
+          </a:xfrm>
+          <a:prstGeom prst="rect">
+            <a:avLst/>
+          </a:prstGeom>
+          <a:solidFill>
+            <a:srgbClr val="334155"/>
+          </a:solidFill>
+          <a:ln>
+            <a:noFill/>
+          </a:ln>
+        </p:spPr>
+        <p:style>
+          <a:lnRef idx="1">
+            <a:schemeClr val="accent1"/>
+          </a:lnRef>
+          <a:fillRef idx="3">
+            <a:schemeClr val="accent1"/>
+          </a:fillRef>
+          <a:effectRef idx="2">
+            <a:schemeClr val="accent1"/>
+          </a:effectRef>
+          <a:fontRef idx="minor">
+            <a:schemeClr val="lt1"/>
+          </a:fontRef>
+        </p:style>
+        <p:txBody>
+          <a:bodyPr rtlCol="0" anchor="ctr"/>
+          <a:lstStyle/>
+          <a:p>
+            <a:pPr algn="ctr"/>
+          </a:p>
+        </p:txBody>
+      </p:sp>
+      <p:sp>
+        <p:nvSpPr>
+          <p:cNvPr id="6" name="Rounded Rectangle 5"/>
+          <p:cNvSpPr/>
+          <p:nvPr/>
+        </p:nvSpPr>
+        <p:spPr>
+          <a:xfrm>
+            <a:off x="731520" y="1645920"/>
+            <a:ext cx="10728655" cy="4480560"/>
           </a:xfrm>
           <a:prstGeom prst="roundRect">
             <a:avLst/>
@@ -5114,14 +5438,14 @@
       </p:sp>
       <p:sp>
         <p:nvSpPr>
-          <p:cNvPr id="10" name="TextBox 9"/>
+          <p:cNvPr id="7" name="TextBox 6"/>
           <p:cNvSpPr txBox="1"/>
           <p:nvPr/>
         </p:nvSpPr>
         <p:spPr>
           <a:xfrm>
-            <a:off x="6400800" y="1783080"/>
-            <a:ext cx="4846320" cy="365760"/>
+            <a:off x="914400" y="1783080"/>
+            <a:ext cx="10362895" cy="365760"/>
           </a:xfrm>
           <a:prstGeom prst="rect">
             <a:avLst/>
@@ -5135,28 +5459,28 @@
           <a:lstStyle/>
           <a:p>
             <a:pPr>
-              <a:defRPr sz="1400" b="1">
+              <a:defRPr sz="1300" b="1">
                 <a:solidFill>
                   <a:srgbClr val="06B6D4"/>
                 </a:solidFill>
               </a:defRPr>
             </a:pPr>
             <a:r>
-              <a:t>PANEL 2 VIVA PRESENTATION</a:t>
-            </a:r>
-          </a:p>
-        </p:txBody>
-      </p:sp>
-      <p:sp>
-        <p:nvSpPr>
-          <p:cNvPr id="11" name="TextBox 10"/>
+              <a:t>MULTI-CLOUD DEPLOYMENT ARCHITECTURE</a:t>
+            </a:r>
+          </a:p>
+        </p:txBody>
+      </p:sp>
+      <p:sp>
+        <p:nvSpPr>
+          <p:cNvPr id="8" name="TextBox 7"/>
           <p:cNvSpPr txBox="1"/>
           <p:nvPr/>
         </p:nvSpPr>
         <p:spPr>
           <a:xfrm>
-            <a:off x="6400800" y="2194560"/>
-            <a:ext cx="4846320" cy="3749039"/>
+            <a:off x="1005840" y="2194560"/>
+            <a:ext cx="10149840" cy="3749039"/>
           </a:xfrm>
           <a:prstGeom prst="rect">
             <a:avLst/>
@@ -5170,64 +5494,142 @@
           <a:lstStyle/>
           <a:p>
             <a:pPr>
-              <a:defRPr sz="2800" b="1">
+              <a:defRPr sz="1300" b="1">
                 <a:solidFill>
                   <a:srgbClr val="10B981"/>
                 </a:solidFill>
               </a:defRPr>
             </a:pPr>
             <a:r>
-              <a:t>Thank You!</a:t>
-            </a:r>
-            <a:br/>
-          </a:p>
-          <a:p>
-            <a:pPr>
-              <a:defRPr sz="1200">
+              <a:t>Production Deployments (Mandated by Department for Final Presentation):</a:t>
+            </a:r>
+          </a:p>
+          <a:p>
+            <a:r>
+              <a:rPr sz="1200" b="1">
+                <a:solidFill>
+                  <a:srgbClr val="10B981"/>
+                </a:solidFill>
+              </a:rPr>
+              <a:t>
+1. Primary Production Deployment: GitHub Pages (Direct Edge CDN)
+</a:t>
+            </a:r>
+            <a:r>
+              <a:rPr sz="1100">
                 <a:solidFill>
                   <a:srgbClr val="F8FAFC"/>
                 </a:solidFill>
-              </a:defRPr>
-            </a:pPr>
-            <a:r>
-              <a:t>HARMONY: Computational Transparency for Shared Living</a:t>
-            </a:r>
-            <a:br/>
-            <a:br/>
-            <a:r>
-              <a:t>Candidate: Lakshya Shukla (Roll No: 240919106121)</a:t>
-            </a:r>
-            <a:br/>
-            <a:r>
-              <a:t>Project Guide: Mr. Nihal Kumar, Assistant Professor</a:t>
-            </a:r>
-            <a:br/>
-            <a:r>
-              <a:t>Department of Information Technology, IMS Noida</a:t>
-            </a:r>
-            <a:br/>
-            <a:r>
-              <a:t>Affiliated to Ch. Charan Singh University, Meerut</a:t>
-            </a:r>
-            <a:br/>
-            <a:br/>
-            <a:r>
-              <a:t>Open for Final Presentation Questions from Panel 2:</a:t>
-            </a:r>
-            <a:br/>
-            <a:r>
-              <a:t>• Mr. Nihal Kumar</a:t>
-            </a:r>
-            <a:br/>
-            <a:r>
-              <a:t>• Ms. Shaili Nigam</a:t>
-            </a:r>
-          </a:p>
-        </p:txBody>
-      </p:sp>
-      <p:sp>
-        <p:nvSpPr>
-          <p:cNvPr id="12" name="TextBox 11"/>
+              </a:rPr>
+              <a:t>   • Zero cold-start latency, hosted directly on the candidate's GitHub account.
+   • Direct Clickable Live URL: </a:t>
+            </a:r>
+            <a:r>
+              <a:rPr sz="1200" b="1" u="sng">
+                <a:solidFill>
+                  <a:srgbClr val="06B6D4"/>
+                </a:solidFill>
+                <a:hlinkClick r:id="rId2"/>
+              </a:rPr>
+              <a:t>https://lakshya212.github.io/HARMONY/
+</a:t>
+            </a:r>
+          </a:p>
+          <a:p>
+            <a:r>
+              <a:rPr sz="1200" b="1">
+                <a:solidFill>
+                  <a:srgbClr val="06B6D4"/>
+                </a:solidFill>
+              </a:rPr>
+              <a:t>2. Secondary Production Deployment: Vercel Edge Network
+</a:t>
+            </a:r>
+            <a:r>
+              <a:rPr sz="1100">
+                <a:solidFill>
+                  <a:srgbClr val="F8FAFC"/>
+                </a:solidFill>
+              </a:rPr>
+              <a:t>   • Built with Vite, bundled to /dist, distributed globally across CDN edge points.
+   • Direct Clickable Live URL: </a:t>
+            </a:r>
+            <a:r>
+              <a:rPr sz="1200" b="1" u="sng">
+                <a:solidFill>
+                  <a:srgbClr val="06B6D4"/>
+                </a:solidFill>
+                <a:hlinkClick r:id="rId3"/>
+              </a:rPr>
+              <a:t>https://harmony-household.vercel.app
+</a:t>
+            </a:r>
+          </a:p>
+          <a:p>
+            <a:r>
+              <a:rPr sz="1200" b="1">
+                <a:solidFill>
+                  <a:srgbClr val="8B5CF6"/>
+                </a:solidFill>
+              </a:rPr>
+              <a:t>3. Application Backend API: Render Web Service
+</a:t>
+            </a:r>
+            <a:r>
+              <a:rPr sz="1100">
+                <a:solidFill>
+                  <a:srgbClr val="F8FAFC"/>
+                </a:solidFill>
+              </a:rPr>
+              <a:t>   • Node.js/Express environment with automatic health checks (/api/health).
+   • Direct API Endpoint: </a:t>
+            </a:r>
+            <a:r>
+              <a:rPr sz="1200" b="1" u="sng">
+                <a:solidFill>
+                  <a:srgbClr val="06B6D4"/>
+                </a:solidFill>
+                <a:hlinkClick r:id="rId4"/>
+              </a:rPr>
+              <a:t>https://harmony-api.onrender.com/api/health
+</a:t>
+            </a:r>
+          </a:p>
+          <a:p>
+            <a:r>
+              <a:rPr sz="1200" b="1">
+                <a:solidFill>
+                  <a:srgbClr val="F59E0B"/>
+                </a:solidFill>
+              </a:rPr>
+              <a:t>4. Public Source Code Repository: GitHub
+</a:t>
+            </a:r>
+            <a:r>
+              <a:rPr sz="1100">
+                <a:solidFill>
+                  <a:srgbClr val="F8FAFC"/>
+                </a:solidFill>
+              </a:rPr>
+              <a:t>   • Complete version history, continuous integration, and full source code.
+   • Repository URL: </a:t>
+            </a:r>
+            <a:r>
+              <a:rPr sz="1200" b="1" u="sng">
+                <a:solidFill>
+                  <a:srgbClr val="06B6D4"/>
+                </a:solidFill>
+                <a:hlinkClick r:id="rId5"/>
+              </a:rPr>
+              <a:t>https://github.com/lakshya212/HARMONY
+</a:t>
+            </a:r>
+          </a:p>
+        </p:txBody>
+      </p:sp>
+      <p:sp>
+        <p:nvSpPr>
+          <p:cNvPr id="9" name="TextBox 8"/>
           <p:cNvSpPr txBox="1"/>
           <p:nvPr/>
         </p:nvSpPr>
@@ -5255,7 +5657,534 @@
               </a:defRPr>
             </a:pPr>
             <a:r>
-              <a:t>HARMONY | Candidate: Lakshya Shukla (240919106121) | Guide: Mr. Nihal Kumar | IMS Noida (Panel 2 - Room DG4) | Slide 12 of 12</a:t>
+              <a:t>HARMONY | Candidate: Lakshya Shukla (240919106121) | Guide: Mr. Nihal Kumar | IMS Noida (Panel 2 - Room DG4) | Slide 13 of 14</a:t>
+            </a:r>
+          </a:p>
+        </p:txBody>
+      </p:sp>
+    </p:spTree>
+  </p:cSld>
+  <p:clrMapOvr>
+    <a:masterClrMapping/>
+  </p:clrMapOvr>
+</p:sld>
+</file>
+
+<file path=ppt/slides/slide14.xml><?xml version="1.0" encoding="utf-8"?>
+<p:sld xmlns:a="http://schemas.openxmlformats.org/drawingml/2006/main" xmlns:p="http://schemas.openxmlformats.org/presentationml/2006/main" xmlns:r="http://schemas.openxmlformats.org/officeDocument/2006/relationships">
+  <p:cSld>
+    <p:spTree>
+      <p:nvGrpSpPr>
+        <p:cNvPr id="1" name=""/>
+        <p:cNvGrpSpPr/>
+        <p:nvPr/>
+      </p:nvGrpSpPr>
+      <p:grpSpPr/>
+      <p:sp>
+        <p:nvSpPr>
+          <p:cNvPr id="2" name="Rectangle 1"/>
+          <p:cNvSpPr/>
+          <p:nvPr/>
+        </p:nvSpPr>
+        <p:spPr>
+          <a:xfrm>
+            <a:off x="0" y="0"/>
+            <a:ext cx="12191695" cy="6858000"/>
+          </a:xfrm>
+          <a:prstGeom prst="rect">
+            <a:avLst/>
+          </a:prstGeom>
+          <a:solidFill>
+            <a:srgbClr val="0F172A"/>
+          </a:solidFill>
+          <a:ln>
+            <a:noFill/>
+          </a:ln>
+        </p:spPr>
+        <p:style>
+          <a:lnRef idx="1">
+            <a:schemeClr val="accent1"/>
+          </a:lnRef>
+          <a:fillRef idx="3">
+            <a:schemeClr val="accent1"/>
+          </a:fillRef>
+          <a:effectRef idx="2">
+            <a:schemeClr val="accent1"/>
+          </a:effectRef>
+          <a:fontRef idx="minor">
+            <a:schemeClr val="lt1"/>
+          </a:fontRef>
+        </p:style>
+        <p:txBody>
+          <a:bodyPr rtlCol="0" anchor="ctr"/>
+          <a:lstStyle/>
+          <a:p>
+            <a:pPr algn="ctr"/>
+          </a:p>
+        </p:txBody>
+      </p:sp>
+      <p:sp>
+        <p:nvSpPr>
+          <p:cNvPr id="3" name="TextBox 2"/>
+          <p:cNvSpPr txBox="1"/>
+          <p:nvPr/>
+        </p:nvSpPr>
+        <p:spPr>
+          <a:xfrm>
+            <a:off x="731520" y="365760"/>
+            <a:ext cx="10698480" cy="365760"/>
+          </a:xfrm>
+          <a:prstGeom prst="rect">
+            <a:avLst/>
+          </a:prstGeom>
+          <a:noFill/>
+        </p:spPr>
+        <p:txBody>
+          <a:bodyPr wrap="square" lIns="0" tIns="0" rIns="0" bIns="0">
+            <a:spAutoFit/>
+          </a:bodyPr>
+          <a:lstStyle/>
+          <a:p>
+            <a:pPr>
+              <a:defRPr sz="1100" b="1">
+                <a:solidFill>
+                  <a:srgbClr val="10B981"/>
+                </a:solidFill>
+              </a:defRPr>
+            </a:pPr>
+            <a:r>
+              <a:t>MINOR PROJECT STATUS: 100% COMPLETE &amp; DEPLOYED</a:t>
+            </a:r>
+          </a:p>
+        </p:txBody>
+      </p:sp>
+      <p:sp>
+        <p:nvSpPr>
+          <p:cNvPr id="4" name="TextBox 3"/>
+          <p:cNvSpPr txBox="1"/>
+          <p:nvPr/>
+        </p:nvSpPr>
+        <p:spPr>
+          <a:xfrm>
+            <a:off x="731520" y="685800"/>
+            <a:ext cx="10698480" cy="640080"/>
+          </a:xfrm>
+          <a:prstGeom prst="rect">
+            <a:avLst/>
+          </a:prstGeom>
+          <a:noFill/>
+        </p:spPr>
+        <p:txBody>
+          <a:bodyPr wrap="square" lIns="0" tIns="0" rIns="0" bIns="0">
+            <a:spAutoFit/>
+          </a:bodyPr>
+          <a:lstStyle/>
+          <a:p>
+            <a:pPr>
+              <a:defRPr sz="2300" b="1">
+                <a:solidFill>
+                  <a:srgbClr val="F8FAFC"/>
+                </a:solidFill>
+              </a:defRPr>
+            </a:pPr>
+            <a:r>
+              <a:t>Final Presentation Summary &amp; Viva Defense</a:t>
+            </a:r>
+          </a:p>
+        </p:txBody>
+      </p:sp>
+      <p:sp>
+        <p:nvSpPr>
+          <p:cNvPr id="5" name="Rectangle 4"/>
+          <p:cNvSpPr/>
+          <p:nvPr/>
+        </p:nvSpPr>
+        <p:spPr>
+          <a:xfrm>
+            <a:off x="731520" y="1371600"/>
+            <a:ext cx="10728655" cy="18288"/>
+          </a:xfrm>
+          <a:prstGeom prst="rect">
+            <a:avLst/>
+          </a:prstGeom>
+          <a:solidFill>
+            <a:srgbClr val="334155"/>
+          </a:solidFill>
+          <a:ln>
+            <a:noFill/>
+          </a:ln>
+        </p:spPr>
+        <p:style>
+          <a:lnRef idx="1">
+            <a:schemeClr val="accent1"/>
+          </a:lnRef>
+          <a:fillRef idx="3">
+            <a:schemeClr val="accent1"/>
+          </a:fillRef>
+          <a:effectRef idx="2">
+            <a:schemeClr val="accent1"/>
+          </a:effectRef>
+          <a:fontRef idx="minor">
+            <a:schemeClr val="lt1"/>
+          </a:fontRef>
+        </p:style>
+        <p:txBody>
+          <a:bodyPr rtlCol="0" anchor="ctr"/>
+          <a:lstStyle/>
+          <a:p>
+            <a:pPr algn="ctr"/>
+          </a:p>
+        </p:txBody>
+      </p:sp>
+      <p:sp>
+        <p:nvSpPr>
+          <p:cNvPr id="6" name="Rounded Rectangle 5"/>
+          <p:cNvSpPr/>
+          <p:nvPr/>
+        </p:nvSpPr>
+        <p:spPr>
+          <a:xfrm>
+            <a:off x="731520" y="1645920"/>
+            <a:ext cx="5120640" cy="4480560"/>
+          </a:xfrm>
+          <a:prstGeom prst="roundRect">
+            <a:avLst/>
+          </a:prstGeom>
+          <a:solidFill>
+            <a:srgbClr val="1E293B"/>
+          </a:solidFill>
+          <a:ln w="12700">
+            <a:solidFill>
+              <a:srgbClr val="334155"/>
+            </a:solidFill>
+          </a:ln>
+        </p:spPr>
+        <p:style>
+          <a:lnRef idx="1">
+            <a:schemeClr val="accent1"/>
+          </a:lnRef>
+          <a:fillRef idx="3">
+            <a:schemeClr val="accent1"/>
+          </a:fillRef>
+          <a:effectRef idx="2">
+            <a:schemeClr val="accent1"/>
+          </a:effectRef>
+          <a:fontRef idx="minor">
+            <a:schemeClr val="lt1"/>
+          </a:fontRef>
+        </p:style>
+        <p:txBody>
+          <a:bodyPr rtlCol="0" anchor="ctr"/>
+          <a:lstStyle/>
+          <a:p>
+            <a:pPr algn="ctr"/>
+          </a:p>
+        </p:txBody>
+      </p:sp>
+      <p:sp>
+        <p:nvSpPr>
+          <p:cNvPr id="7" name="TextBox 6"/>
+          <p:cNvSpPr txBox="1"/>
+          <p:nvPr/>
+        </p:nvSpPr>
+        <p:spPr>
+          <a:xfrm>
+            <a:off x="914400" y="1783080"/>
+            <a:ext cx="4754880" cy="365760"/>
+          </a:xfrm>
+          <a:prstGeom prst="rect">
+            <a:avLst/>
+          </a:prstGeom>
+          <a:noFill/>
+        </p:spPr>
+        <p:txBody>
+          <a:bodyPr wrap="square" lIns="0" tIns="0" rIns="0" bIns="0">
+            <a:spAutoFit/>
+          </a:bodyPr>
+          <a:lstStyle/>
+          <a:p>
+            <a:pPr>
+              <a:defRPr sz="1300" b="1">
+                <a:solidFill>
+                  <a:srgbClr val="06B6D4"/>
+                </a:solidFill>
+              </a:defRPr>
+            </a:pPr>
+            <a:r>
+              <a:t>FINAL DELIVERABLES READY</a:t>
+            </a:r>
+          </a:p>
+        </p:txBody>
+      </p:sp>
+      <p:sp>
+        <p:nvSpPr>
+          <p:cNvPr id="8" name="TextBox 7"/>
+          <p:cNvSpPr txBox="1"/>
+          <p:nvPr/>
+        </p:nvSpPr>
+        <p:spPr>
+          <a:xfrm>
+            <a:off x="914400" y="2194560"/>
+            <a:ext cx="4754880" cy="3749039"/>
+          </a:xfrm>
+          <a:prstGeom prst="rect">
+            <a:avLst/>
+          </a:prstGeom>
+          <a:noFill/>
+        </p:spPr>
+        <p:txBody>
+          <a:bodyPr wrap="square">
+            <a:spAutoFit/>
+          </a:bodyPr>
+          <a:lstStyle/>
+          <a:p>
+            <a:pPr>
+              <a:defRPr sz="1050">
+                <a:solidFill>
+                  <a:srgbClr val="F8FAFC"/>
+                </a:solidFill>
+              </a:defRPr>
+            </a:pPr>
+            <a:r>
+              <a:t>Mandatory Submissions for Panel 2:</a:t>
+            </a:r>
+            <a:br/>
+            <a:br/>
+            <a:r>
+              <a:t>[X] PDF of Project Along with Code:</a:t>
+            </a:r>
+            <a:br/>
+            <a:r>
+              <a:t>    56-page comprehensive report with Cannock Pvt Ltd certificate, DFDs, ERD, and Section 12 full source code appendix.</a:t>
+            </a:r>
+            <a:br/>
+            <a:br/>
+            <a:r>
+              <a:t>[X] Project Deployment Link:</a:t>
+            </a:r>
+            <a:br/>
+            <a:r>
+              <a:t>    Production web app live on GitHub Pages &amp; Vercel with resilient client fallback.</a:t>
+            </a:r>
+            <a:br/>
+            <a:br/>
+            <a:r>
+              <a:t>[X] PPT for Presentation (Mandatory):</a:t>
+            </a:r>
+            <a:br/>
+            <a:r>
+              <a:t>    14-slide master presentation with live clickable links.</a:t>
+            </a:r>
+            <a:br/>
+            <a:br/>
+            <a:r>
+              <a:t>[X] Standalone Source Code Booklet:</a:t>
+            </a:r>
+            <a:br/>
+            <a:r>
+              <a:t>    29-page dedicated code listing in Consolas monospace format.</a:t>
+            </a:r>
+            <a:br/>
+            <a:br/>
+            <a:r>
+              <a:t>[X] GitHub Source Code Repository:</a:t>
+            </a:r>
+            <a:br/>
+            <a:r>
+              <a:t>    Publicly accessible at github.com/lakshya212/HARMONY.</a:t>
+            </a:r>
+          </a:p>
+        </p:txBody>
+      </p:sp>
+      <p:sp>
+        <p:nvSpPr>
+          <p:cNvPr id="9" name="Rounded Rectangle 8"/>
+          <p:cNvSpPr/>
+          <p:nvPr/>
+        </p:nvSpPr>
+        <p:spPr>
+          <a:xfrm>
+            <a:off x="6217920" y="1645920"/>
+            <a:ext cx="5212080" cy="4480560"/>
+          </a:xfrm>
+          <a:prstGeom prst="roundRect">
+            <a:avLst/>
+          </a:prstGeom>
+          <a:solidFill>
+            <a:srgbClr val="1E293B"/>
+          </a:solidFill>
+          <a:ln w="12700">
+            <a:solidFill>
+              <a:srgbClr val="10B981"/>
+            </a:solidFill>
+          </a:ln>
+        </p:spPr>
+        <p:style>
+          <a:lnRef idx="1">
+            <a:schemeClr val="accent1"/>
+          </a:lnRef>
+          <a:fillRef idx="3">
+            <a:schemeClr val="accent1"/>
+          </a:fillRef>
+          <a:effectRef idx="2">
+            <a:schemeClr val="accent1"/>
+          </a:effectRef>
+          <a:fontRef idx="minor">
+            <a:schemeClr val="lt1"/>
+          </a:fontRef>
+        </p:style>
+        <p:txBody>
+          <a:bodyPr rtlCol="0" anchor="ctr"/>
+          <a:lstStyle/>
+          <a:p>
+            <a:pPr algn="ctr"/>
+          </a:p>
+        </p:txBody>
+      </p:sp>
+      <p:sp>
+        <p:nvSpPr>
+          <p:cNvPr id="10" name="TextBox 9"/>
+          <p:cNvSpPr txBox="1"/>
+          <p:nvPr/>
+        </p:nvSpPr>
+        <p:spPr>
+          <a:xfrm>
+            <a:off x="6400800" y="1783080"/>
+            <a:ext cx="4846320" cy="365760"/>
+          </a:xfrm>
+          <a:prstGeom prst="rect">
+            <a:avLst/>
+          </a:prstGeom>
+          <a:noFill/>
+        </p:spPr>
+        <p:txBody>
+          <a:bodyPr wrap="square" lIns="0" tIns="0" rIns="0" bIns="0">
+            <a:spAutoFit/>
+          </a:bodyPr>
+          <a:lstStyle/>
+          <a:p>
+            <a:pPr>
+              <a:defRPr sz="1300" b="1">
+                <a:solidFill>
+                  <a:srgbClr val="06B6D4"/>
+                </a:solidFill>
+              </a:defRPr>
+            </a:pPr>
+            <a:r>
+              <a:t>PANEL 2 VIVA PRESENTATION</a:t>
+            </a:r>
+          </a:p>
+        </p:txBody>
+      </p:sp>
+      <p:sp>
+        <p:nvSpPr>
+          <p:cNvPr id="11" name="TextBox 10"/>
+          <p:cNvSpPr txBox="1"/>
+          <p:nvPr/>
+        </p:nvSpPr>
+        <p:spPr>
+          <a:xfrm>
+            <a:off x="6400800" y="2194560"/>
+            <a:ext cx="4846320" cy="3749039"/>
+          </a:xfrm>
+          <a:prstGeom prst="rect">
+            <a:avLst/>
+          </a:prstGeom>
+          <a:noFill/>
+        </p:spPr>
+        <p:txBody>
+          <a:bodyPr wrap="square">
+            <a:spAutoFit/>
+          </a:bodyPr>
+          <a:lstStyle/>
+          <a:p>
+            <a:pPr>
+              <a:defRPr sz="2800" b="1">
+                <a:solidFill>
+                  <a:srgbClr val="10B981"/>
+                </a:solidFill>
+              </a:defRPr>
+            </a:pPr>
+            <a:r>
+              <a:t>Thank You!</a:t>
+            </a:r>
+            <a:br/>
+          </a:p>
+          <a:p>
+            <a:pPr>
+              <a:defRPr sz="1200">
+                <a:solidFill>
+                  <a:srgbClr val="F8FAFC"/>
+                </a:solidFill>
+              </a:defRPr>
+            </a:pPr>
+            <a:r>
+              <a:t>HARMONY: Computational Transparency for Shared Living</a:t>
+            </a:r>
+            <a:br/>
+            <a:br/>
+            <a:r>
+              <a:t>Candidate: Lakshya Shukla (Roll No: 240919106121)</a:t>
+            </a:r>
+            <a:br/>
+            <a:r>
+              <a:t>Project Guide: Mr. Nihal Kumar, Assistant Professor</a:t>
+            </a:r>
+            <a:br/>
+            <a:r>
+              <a:t>Department of Information Technology, IMS Noida</a:t>
+            </a:r>
+            <a:br/>
+            <a:r>
+              <a:t>Affiliated to Ch. Charan Singh University, Meerut</a:t>
+            </a:r>
+            <a:br/>
+            <a:br/>
+            <a:r>
+              <a:t>Open for Final Presentation Questions from Panel 2:</a:t>
+            </a:r>
+            <a:br/>
+            <a:r>
+              <a:t>• Mr. Nihal Kumar</a:t>
+            </a:r>
+            <a:br/>
+            <a:r>
+              <a:t>• Ms. Shaili Nigam</a:t>
+            </a:r>
+          </a:p>
+        </p:txBody>
+      </p:sp>
+      <p:sp>
+        <p:nvSpPr>
+          <p:cNvPr id="12" name="TextBox 11"/>
+          <p:cNvSpPr txBox="1"/>
+          <p:nvPr/>
+        </p:nvSpPr>
+        <p:spPr>
+          <a:xfrm>
+            <a:off x="731520" y="6400800"/>
+            <a:ext cx="10728655" cy="320040"/>
+          </a:xfrm>
+          <a:prstGeom prst="rect">
+            <a:avLst/>
+          </a:prstGeom>
+          <a:noFill/>
+        </p:spPr>
+        <p:txBody>
+          <a:bodyPr wrap="none" lIns="0" tIns="0" rIns="0" bIns="0">
+            <a:spAutoFit/>
+          </a:bodyPr>
+          <a:lstStyle/>
+          <a:p>
+            <a:pPr>
+              <a:defRPr sz="900">
+                <a:solidFill>
+                  <a:srgbClr val="94A3B8"/>
+                </a:solidFill>
+              </a:defRPr>
+            </a:pPr>
+            <a:r>
+              <a:t>HARMONY | Candidate: Lakshya Shukla (240919106121) | Guide: Mr. Nihal Kumar | IMS Noida (Panel 2 - Room DG4) | Slide 14 of 14</a:t>
             </a:r>
           </a:p>
         </p:txBody>
@@ -5379,7 +6308,7 @@
           <a:lstStyle/>
           <a:p>
             <a:pPr>
-              <a:defRPr sz="2400" b="1">
+              <a:defRPr sz="2300" b="1">
                 <a:solidFill>
                   <a:srgbClr val="F8FAFC"/>
                 </a:solidFill>
@@ -5502,7 +6431,7 @@
           <a:lstStyle/>
           <a:p>
             <a:pPr>
-              <a:defRPr sz="1400" b="1">
+              <a:defRPr sz="1300" b="1">
                 <a:solidFill>
                   <a:srgbClr val="06B6D4"/>
                 </a:solidFill>
@@ -5632,7 +6561,7 @@
           <a:lstStyle/>
           <a:p>
             <a:pPr>
-              <a:defRPr sz="1400" b="1">
+              <a:defRPr sz="1300" b="1">
                 <a:solidFill>
                   <a:srgbClr val="06B6D4"/>
                 </a:solidFill>
@@ -5767,7 +6696,7 @@
           <a:lstStyle/>
           <a:p>
             <a:pPr>
-              <a:defRPr sz="1400" b="1">
+              <a:defRPr sz="1300" b="1">
                 <a:solidFill>
                   <a:srgbClr val="06B6D4"/>
                 </a:solidFill>
@@ -5864,7 +6793,7 @@
               </a:defRPr>
             </a:pPr>
             <a:r>
-              <a:t>HARMONY | Candidate: Lakshya Shukla (240919106121) | Guide: Mr. Nihal Kumar | IMS Noida (Panel 2 - Room DG4) | Slide 2 of 12</a:t>
+              <a:t>HARMONY | Candidate: Lakshya Shukla (240919106121) | Guide: Mr. Nihal Kumar | IMS Noida (Panel 2 - Room DG4) | Slide 2 of 14</a:t>
             </a:r>
           </a:p>
         </p:txBody>
@@ -5988,7 +6917,7 @@
           <a:lstStyle/>
           <a:p>
             <a:pPr>
-              <a:defRPr sz="2400" b="1">
+              <a:defRPr sz="2300" b="1">
                 <a:solidFill>
                   <a:srgbClr val="F8FAFC"/>
                 </a:solidFill>
@@ -6135,7 +7064,7 @@
           <a:lstStyle/>
           <a:p>
             <a:pPr>
-              <a:defRPr sz="1400" b="1">
+              <a:defRPr sz="1300" b="1">
                 <a:solidFill>
                   <a:srgbClr val="06B6D4"/>
                 </a:solidFill>
@@ -6258,7 +7187,7 @@
               </a:defRPr>
             </a:pPr>
             <a:r>
-              <a:t>HARMONY | Candidate: Lakshya Shukla (240919106121) | Guide: Mr. Nihal Kumar | IMS Noida (Panel 2 - Room DG4) | Slide 3 of 12</a:t>
+              <a:t>HARMONY | Candidate: Lakshya Shukla (240919106121) | Guide: Mr. Nihal Kumar | IMS Noida (Panel 2 - Room DG4) | Slide 3 of 14</a:t>
             </a:r>
           </a:p>
         </p:txBody>
@@ -6382,7 +7311,7 @@
           <a:lstStyle/>
           <a:p>
             <a:pPr>
-              <a:defRPr sz="2400" b="1">
+              <a:defRPr sz="2300" b="1">
                 <a:solidFill>
                   <a:srgbClr val="F8FAFC"/>
                 </a:solidFill>
@@ -6505,7 +7434,7 @@
           <a:lstStyle/>
           <a:p>
             <a:pPr>
-              <a:defRPr sz="1400" b="1">
+              <a:defRPr sz="1300" b="1">
                 <a:solidFill>
                   <a:srgbClr val="06B6D4"/>
                 </a:solidFill>
@@ -6644,7 +7573,7 @@
           <a:lstStyle/>
           <a:p>
             <a:pPr>
-              <a:defRPr sz="1400" b="1">
+              <a:defRPr sz="1300" b="1">
                 <a:solidFill>
                   <a:srgbClr val="06B6D4"/>
                 </a:solidFill>
@@ -6745,7 +7674,7 @@
               </a:defRPr>
             </a:pPr>
             <a:r>
-              <a:t>HARMONY | Candidate: Lakshya Shukla (240919106121) | Guide: Mr. Nihal Kumar | IMS Noida (Panel 2 - Room DG4) | Slide 4 of 12</a:t>
+              <a:t>HARMONY | Candidate: Lakshya Shukla (240919106121) | Guide: Mr. Nihal Kumar | IMS Noida (Panel 2 - Room DG4) | Slide 4 of 14</a:t>
             </a:r>
           </a:p>
         </p:txBody>
@@ -6869,14 +7798,14 @@
           <a:lstStyle/>
           <a:p>
             <a:pPr>
-              <a:defRPr sz="2400" b="1">
+              <a:defRPr sz="2300" b="1">
                 <a:solidFill>
                   <a:srgbClr val="F8FAFC"/>
                 </a:solidFill>
               </a:defRPr>
             </a:pPr>
             <a:r>
-              <a:t>Relational Database Design &amp; Entity Relationships</a:t>
+              <a:t>DFD Level 2: Expense Calculation &amp; Settlement Engine</a:t>
             </a:r>
           </a:p>
         </p:txBody>
@@ -6926,7 +7855,7 @@
       </p:sp>
       <p:pic>
         <p:nvPicPr>
-          <p:cNvPr id="6" name="Picture 5" descr="diagram_erd.png"/>
+          <p:cNvPr id="6" name="Picture 5" descr="diagram_dfd2.png"/>
           <p:cNvPicPr>
             <a:picLocks noChangeAspect="1"/>
           </p:cNvPicPr>
@@ -7016,14 +7945,14 @@
           <a:lstStyle/>
           <a:p>
             <a:pPr>
-              <a:defRPr sz="1400" b="1">
+              <a:defRPr sz="1300" b="1">
                 <a:solidFill>
                   <a:srgbClr val="06B6D4"/>
                 </a:solidFill>
               </a:defRPr>
             </a:pPr>
             <a:r>
-              <a:t>SCHEMA STRUCTURE &amp; INTEGRITY</a:t>
+              <a:t>SUB-PROCESS DECOMPOSITION</a:t>
             </a:r>
           </a:p>
         </p:txBody>
@@ -7051,73 +7980,63 @@
           <a:lstStyle/>
           <a:p>
             <a:pPr>
-              <a:defRPr sz="1000">
+              <a:defRPr sz="1050">
                 <a:solidFill>
                   <a:srgbClr val="F8FAFC"/>
                 </a:solidFill>
               </a:defRPr>
             </a:pPr>
             <a:r>
-              <a:t>Relational Entities (PostgreSQL 3NF):</a:t>
-            </a:r>
-            <a:br/>
-            <a:br/>
-            <a:r>
-              <a:t>1. users:</a:t>
-            </a:r>
-            <a:br/>
-            <a:r>
-              <a:t>   UUID primary key, email (unique), full_name, role.</a:t>
-            </a:r>
-            <a:br/>
-            <a:br/>
-            <a:r>
-              <a:t>2. households:</a:t>
-            </a:r>
-            <a:br/>
-            <a:r>
-              <a:t>   id, household_name, invite_code (unique index), created_by.</a:t>
-            </a:r>
-            <a:br/>
-            <a:br/>
-            <a:r>
-              <a:t>3. household_members (Junction):</a:t>
-            </a:r>
-            <a:br/>
-            <a:r>
-              <a:t>   household_id (FK), user_id (FK), joined_at, role (Admin/Member).</a:t>
-            </a:r>
-            <a:br/>
-            <a:br/>
-            <a:r>
-              <a:t>4. chores:</a:t>
-            </a:r>
-            <a:br/>
-            <a:r>
-              <a:t>   id, household_id (FK), title, points (10-30), assigned_to (FK), status (pending/completed).</a:t>
-            </a:r>
-            <a:br/>
-            <a:br/>
-            <a:r>
-              <a:t>5. expenses:</a:t>
-            </a:r>
-            <a:br/>
-            <a:r>
-              <a:t>   id, household_id (FK), title, amount, category, payer_id (FK), date.</a:t>
-            </a:r>
-            <a:br/>
-            <a:br/>
-            <a:r>
-              <a:t>6. expense_splits:</a:t>
-            </a:r>
-            <a:br/>
-            <a:r>
-              <a:t>   expense_id (FK), user_id (FK), owed_amount, is_settled.</a:t>
-            </a:r>
-            <a:br/>
-            <a:br/>
-            <a:r>
-              <a:t>Referential Integrity: ON DELETE CASCADE applied to household joins to prevent orphan ledger records.</a:t>
+              <a:t>Process 4.0 Detailed Breakdown:</a:t>
+            </a:r>
+            <a:br/>
+            <a:br/>
+            <a:r>
+              <a:t>• 4.1 Validate Expense Input:</a:t>
+            </a:r>
+            <a:br/>
+            <a:r>
+              <a:t>  Checks bill amount &gt; 0, verifies category (groceries, utilities, etc.), and validates payer identity.</a:t>
+            </a:r>
+            <a:br/>
+            <a:br/>
+            <a:r>
+              <a:t>• 4.2 Compute Participant Shares:</a:t>
+            </a:r>
+            <a:br/>
+            <a:r>
+              <a:t>  Calculates equal division: Share = Total Amount / N participants.</a:t>
+            </a:r>
+            <a:br/>
+            <a:br/>
+            <a:r>
+              <a:t>• 4.3 Update Member Net Balances:</a:t>
+            </a:r>
+            <a:br/>
+            <a:r>
+              <a:t>  Payer: Balance += (Total - Share)</a:t>
+            </a:r>
+            <a:br/>
+            <a:r>
+              <a:t>  Participants: Balance -= Share</a:t>
+            </a:r>
+            <a:br/>
+            <a:br/>
+            <a:r>
+              <a:t>• 4.4 Persist Transaction to Ledger:</a:t>
+            </a:r>
+            <a:br/>
+            <a:r>
+              <a:t>  Atomic write to expenses and expense_splits tables with referential integrity.</a:t>
+            </a:r>
+            <a:br/>
+            <a:br/>
+            <a:r>
+              <a:t>• 4.5 Invariant Guarantee:</a:t>
+            </a:r>
+            <a:br/>
+            <a:r>
+              <a:t>  Net balance equilibrium strictly enforced across all members.</a:t>
             </a:r>
           </a:p>
         </p:txBody>
@@ -7152,7 +8071,7 @@
               </a:defRPr>
             </a:pPr>
             <a:r>
-              <a:t>HARMONY | Candidate: Lakshya Shukla (240919106121) | Guide: Mr. Nihal Kumar | IMS Noida (Panel 2 - Room DG4) | Slide 5 of 12</a:t>
+              <a:t>HARMONY | Candidate: Lakshya Shukla (240919106121) | Guide: Mr. Nihal Kumar | IMS Noida (Panel 2 - Room DG4) | Slide 5 of 14</a:t>
             </a:r>
           </a:p>
         </p:txBody>
@@ -7276,14 +8195,14 @@
           <a:lstStyle/>
           <a:p>
             <a:pPr>
-              <a:defRPr sz="2400" b="1">
+              <a:defRPr sz="2300" b="1">
                 <a:solidFill>
                   <a:srgbClr val="F8FAFC"/>
                 </a:solidFill>
               </a:defRPr>
             </a:pPr>
             <a:r>
-              <a:t>Core Module 1: Automated Expense Splitting &amp; Ledger</a:t>
+              <a:t>Relational Database Design &amp; Entity Relationships</a:t>
             </a:r>
           </a:p>
         </p:txBody>
@@ -7331,16 +8250,40 @@
           </a:p>
         </p:txBody>
       </p:sp>
-      <p:sp>
-        <p:nvSpPr>
-          <p:cNvPr id="6" name="Rounded Rectangle 5"/>
+      <p:pic>
+        <p:nvPicPr>
+          <p:cNvPr id="6" name="Picture 5" descr="diagram_erd.png"/>
+          <p:cNvPicPr>
+            <a:picLocks noChangeAspect="1"/>
+          </p:cNvPicPr>
+          <p:nvPr/>
+        </p:nvPicPr>
+        <p:blipFill>
+          <a:blip r:embed="rId2"/>
+          <a:stretch>
+            <a:fillRect/>
+          </a:stretch>
+        </p:blipFill>
+        <p:spPr>
+          <a:xfrm>
+            <a:off x="731520" y="1645920"/>
+            <a:ext cx="5669280" cy="4480560"/>
+          </a:xfrm>
+          <a:prstGeom prst="rect">
+            <a:avLst/>
+          </a:prstGeom>
+        </p:spPr>
+      </p:pic>
+      <p:sp>
+        <p:nvSpPr>
+          <p:cNvPr id="7" name="Rounded Rectangle 6"/>
           <p:cNvSpPr/>
           <p:nvPr/>
         </p:nvSpPr>
         <p:spPr>
           <a:xfrm>
-            <a:off x="731520" y="1645920"/>
-            <a:ext cx="5120640" cy="4480560"/>
+            <a:off x="6675120" y="1645920"/>
+            <a:ext cx="4754880" cy="4480560"/>
           </a:xfrm>
           <a:prstGeom prst="roundRect">
             <a:avLst/>
@@ -7378,14 +8321,14 @@
       </p:sp>
       <p:sp>
         <p:nvSpPr>
-          <p:cNvPr id="7" name="TextBox 6"/>
+          <p:cNvPr id="8" name="TextBox 7"/>
           <p:cNvSpPr txBox="1"/>
           <p:nvPr/>
         </p:nvSpPr>
         <p:spPr>
           <a:xfrm>
-            <a:off x="914400" y="1783080"/>
-            <a:ext cx="4754880" cy="365760"/>
+            <a:off x="6858000" y="1783080"/>
+            <a:ext cx="4389120" cy="365760"/>
           </a:xfrm>
           <a:prstGeom prst="rect">
             <a:avLst/>
@@ -7399,28 +8342,28 @@
           <a:lstStyle/>
           <a:p>
             <a:pPr>
-              <a:defRPr sz="1400" b="1">
+              <a:defRPr sz="1300" b="1">
                 <a:solidFill>
                   <a:srgbClr val="06B6D4"/>
                 </a:solidFill>
               </a:defRPr>
             </a:pPr>
             <a:r>
-              <a:t>MATHEMATICAL SPLIT FORMULATION</a:t>
-            </a:r>
-          </a:p>
-        </p:txBody>
-      </p:sp>
-      <p:sp>
-        <p:nvSpPr>
-          <p:cNvPr id="8" name="TextBox 7"/>
+              <a:t>SCHEMA STRUCTURE &amp; INTEGRITY</a:t>
+            </a:r>
+          </a:p>
+        </p:txBody>
+      </p:sp>
+      <p:sp>
+        <p:nvSpPr>
+          <p:cNvPr id="9" name="TextBox 8"/>
           <p:cNvSpPr txBox="1"/>
           <p:nvPr/>
         </p:nvSpPr>
         <p:spPr>
           <a:xfrm>
-            <a:off x="914400" y="2194560"/>
-            <a:ext cx="4754880" cy="3749039"/>
+            <a:off x="6858000" y="2194560"/>
+            <a:ext cx="4389120" cy="3749039"/>
           </a:xfrm>
           <a:prstGeom prst="rect">
             <a:avLst/>
@@ -7434,221 +8377,80 @@
           <a:lstStyle/>
           <a:p>
             <a:pPr>
-              <a:defRPr sz="1100">
+              <a:defRPr sz="1000">
                 <a:solidFill>
                   <a:srgbClr val="F8FAFC"/>
                 </a:solidFill>
               </a:defRPr>
             </a:pPr>
             <a:r>
-              <a:t>Mathematical Principle of Ledger Equilibrium:</a:t>
-            </a:r>
-            <a:br/>
-            <a:br/>
-            <a:r>
-              <a:t>For any household member i:</a:t>
-            </a:r>
-            <a:br/>
-            <a:r>
-              <a:t>   Net Balance (B_i) = Total Amount Paid (P_i) - Expected Share (S_i)</a:t>
-            </a:r>
-            <a:br/>
-            <a:br/>
-            <a:r>
-              <a:t>Equilibrium Invariant:</a:t>
-            </a:r>
-            <a:br/>
-            <a:r>
-              <a:t>   Sum of all B_i across household = 0</a:t>
-            </a:r>
-            <a:br/>
-            <a:br/>
-            <a:r>
-              <a:t>• Positive Net Balance (+₹X):</a:t>
-            </a:r>
-            <a:br/>
-            <a:r>
-              <a:t>  The member has paid more than their equal share. The group owes this member ₹X. Displayed in Emerald Green.</a:t>
-            </a:r>
-            <a:br/>
-            <a:br/>
-            <a:r>
-              <a:t>• Negative Net Balance (-₹Y):</a:t>
-            </a:r>
-            <a:br/>
-            <a:r>
-              <a:t>  The member has undercontributed or paid less than their share. This member owes ₹Y to the group. Displayed in Amber/Rose.</a:t>
-            </a:r>
-            <a:br/>
-            <a:br/>
-            <a:r>
-              <a:t>• Zero Net Balance (₹0):</a:t>
-            </a:r>
-            <a:br/>
-            <a:r>
-              <a:t>  The member's dues are perfectly settled.</a:t>
-            </a:r>
-          </a:p>
-        </p:txBody>
-      </p:sp>
-      <p:sp>
-        <p:nvSpPr>
-          <p:cNvPr id="9" name="Rounded Rectangle 8"/>
-          <p:cNvSpPr/>
-          <p:nvPr/>
-        </p:nvSpPr>
-        <p:spPr>
-          <a:xfrm>
-            <a:off x="6217920" y="1645920"/>
-            <a:ext cx="5212080" cy="4480560"/>
-          </a:xfrm>
-          <a:prstGeom prst="roundRect">
-            <a:avLst/>
-          </a:prstGeom>
-          <a:solidFill>
-            <a:srgbClr val="1E293B"/>
-          </a:solidFill>
-          <a:ln w="12700">
-            <a:solidFill>
-              <a:srgbClr val="334155"/>
-            </a:solidFill>
-          </a:ln>
-        </p:spPr>
-        <p:style>
-          <a:lnRef idx="1">
-            <a:schemeClr val="accent1"/>
-          </a:lnRef>
-          <a:fillRef idx="3">
-            <a:schemeClr val="accent1"/>
-          </a:fillRef>
-          <a:effectRef idx="2">
-            <a:schemeClr val="accent1"/>
-          </a:effectRef>
-          <a:fontRef idx="minor">
-            <a:schemeClr val="lt1"/>
-          </a:fontRef>
-        </p:style>
-        <p:txBody>
-          <a:bodyPr rtlCol="0" anchor="ctr"/>
-          <a:lstStyle/>
-          <a:p>
-            <a:pPr algn="ctr"/>
+              <a:t>Relational Entities (PostgreSQL 3NF):</a:t>
+            </a:r>
+            <a:br/>
+            <a:br/>
+            <a:r>
+              <a:t>1. users:</a:t>
+            </a:r>
+            <a:br/>
+            <a:r>
+              <a:t>   UUID primary key, email (unique), full_name, role.</a:t>
+            </a:r>
+            <a:br/>
+            <a:br/>
+            <a:r>
+              <a:t>2. households:</a:t>
+            </a:r>
+            <a:br/>
+            <a:r>
+              <a:t>   id, household_name, invite_code (unique index), created_by.</a:t>
+            </a:r>
+            <a:br/>
+            <a:br/>
+            <a:r>
+              <a:t>3. household_members (Junction):</a:t>
+            </a:r>
+            <a:br/>
+            <a:r>
+              <a:t>   household_id (FK), user_id (FK), joined_at, role (Admin/Member).</a:t>
+            </a:r>
+            <a:br/>
+            <a:br/>
+            <a:r>
+              <a:t>4. chores:</a:t>
+            </a:r>
+            <a:br/>
+            <a:r>
+              <a:t>   id, household_id (FK), title, points (10-30), assigned_to (FK), status (pending/completed).</a:t>
+            </a:r>
+            <a:br/>
+            <a:br/>
+            <a:r>
+              <a:t>5. expenses:</a:t>
+            </a:r>
+            <a:br/>
+            <a:r>
+              <a:t>   id, household_id (FK), title, amount, category, payer_id (FK), date.</a:t>
+            </a:r>
+            <a:br/>
+            <a:br/>
+            <a:r>
+              <a:t>6. expense_splits:</a:t>
+            </a:r>
+            <a:br/>
+            <a:r>
+              <a:t>   expense_id (FK), user_id (FK), owed_amount, is_settled.</a:t>
+            </a:r>
+            <a:br/>
+            <a:br/>
+            <a:r>
+              <a:t>Referential Integrity: ON DELETE CASCADE applied to household joins to prevent orphan ledger records.</a:t>
+            </a:r>
           </a:p>
         </p:txBody>
       </p:sp>
       <p:sp>
         <p:nvSpPr>
           <p:cNvPr id="10" name="TextBox 9"/>
-          <p:cNvSpPr txBox="1"/>
-          <p:nvPr/>
-        </p:nvSpPr>
-        <p:spPr>
-          <a:xfrm>
-            <a:off x="6400800" y="1783080"/>
-            <a:ext cx="4846320" cy="365760"/>
-          </a:xfrm>
-          <a:prstGeom prst="rect">
-            <a:avLst/>
-          </a:prstGeom>
-          <a:noFill/>
-        </p:spPr>
-        <p:txBody>
-          <a:bodyPr wrap="square" lIns="0" tIns="0" rIns="0" bIns="0">
-            <a:spAutoFit/>
-          </a:bodyPr>
-          <a:lstStyle/>
-          <a:p>
-            <a:pPr>
-              <a:defRPr sz="1400" b="1">
-                <a:solidFill>
-                  <a:srgbClr val="06B6D4"/>
-                </a:solidFill>
-              </a:defRPr>
-            </a:pPr>
-            <a:r>
-              <a:t>EXPENSE ENGINE CAPABILITIES</a:t>
-            </a:r>
-          </a:p>
-        </p:txBody>
-      </p:sp>
-      <p:sp>
-        <p:nvSpPr>
-          <p:cNvPr id="11" name="TextBox 10"/>
-          <p:cNvSpPr txBox="1"/>
-          <p:nvPr/>
-        </p:nvSpPr>
-        <p:spPr>
-          <a:xfrm>
-            <a:off x="6400800" y="2194560"/>
-            <a:ext cx="4846320" cy="3749039"/>
-          </a:xfrm>
-          <a:prstGeom prst="rect">
-            <a:avLst/>
-          </a:prstGeom>
-          <a:noFill/>
-        </p:spPr>
-        <p:txBody>
-          <a:bodyPr wrap="square">
-            <a:spAutoFit/>
-          </a:bodyPr>
-          <a:lstStyle/>
-          <a:p>
-            <a:pPr>
-              <a:defRPr sz="1100">
-                <a:solidFill>
-                  <a:srgbClr val="F8FAFC"/>
-                </a:solidFill>
-              </a:defRPr>
-            </a:pPr>
-            <a:r>
-              <a:t>Operational Workflow:</a:t>
-            </a:r>
-            <a:br/>
-            <a:br/>
-            <a:r>
-              <a:t>1. Bill Recording:</a:t>
-            </a:r>
-            <a:br/>
-            <a:r>
-              <a:t>   Roommate records expense (e.g. ₹2,400 for Fiber Internet, paid by Lakshya Shukla).</a:t>
-            </a:r>
-            <a:br/>
-            <a:br/>
-            <a:r>
-              <a:t>2. Split Computation:</a:t>
-            </a:r>
-            <a:br/>
-            <a:r>
-              <a:t>   System divides amount equally across all 4 household occupants: ₹600 per occupant.</a:t>
-            </a:r>
-            <a:br/>
-            <a:br/>
-            <a:r>
-              <a:t>3. Ledger Update:</a:t>
-            </a:r>
-            <a:br/>
-            <a:r>
-              <a:t>   • Lakshya Paid: ₹2,400 | Share: ₹600 | Net Balance: +₹1,800</a:t>
-            </a:r>
-            <a:br/>
-            <a:r>
-              <a:t>   • Other 3 Roommates: Paid: ₹0 | Share: ₹600 | Net Balance: -₹600 each</a:t>
-            </a:r>
-            <a:br/>
-            <a:br/>
-            <a:r>
-              <a:t>4. Transparent History:</a:t>
-            </a:r>
-            <a:br/>
-            <a:r>
-              <a:t>   Categorized under Groceries, Utilities, Internet, Supplies with exact timestamps and payer tags.</a:t>
-            </a:r>
-          </a:p>
-        </p:txBody>
-      </p:sp>
-      <p:sp>
-        <p:nvSpPr>
-          <p:cNvPr id="12" name="TextBox 11"/>
           <p:cNvSpPr txBox="1"/>
           <p:nvPr/>
         </p:nvSpPr>
@@ -7676,7 +8478,7 @@
               </a:defRPr>
             </a:pPr>
             <a:r>
-              <a:t>HARMONY | Candidate: Lakshya Shukla (240919106121) | Guide: Mr. Nihal Kumar | IMS Noida (Panel 2 - Room DG4) | Slide 6 of 12</a:t>
+              <a:t>HARMONY | Candidate: Lakshya Shukla (240919106121) | Guide: Mr. Nihal Kumar | IMS Noida (Panel 2 - Room DG4) | Slide 6 of 14</a:t>
             </a:r>
           </a:p>
         </p:txBody>
@@ -7800,14 +8602,14 @@
           <a:lstStyle/>
           <a:p>
             <a:pPr>
-              <a:defRPr sz="2400" b="1">
+              <a:defRPr sz="2300" b="1">
                 <a:solidFill>
                   <a:srgbClr val="F8FAFC"/>
                 </a:solidFill>
               </a:defRPr>
             </a:pPr>
             <a:r>
-              <a:t>Core Module 2: Effort-Weighted Chore Allocation</a:t>
+              <a:t>Use Case Model &amp; System Process Flow</a:t>
             </a:r>
           </a:p>
         </p:txBody>
@@ -7855,302 +8657,57 @@
           </a:p>
         </p:txBody>
       </p:sp>
-      <p:sp>
-        <p:nvSpPr>
-          <p:cNvPr id="6" name="Rounded Rectangle 5"/>
-          <p:cNvSpPr/>
-          <p:nvPr/>
-        </p:nvSpPr>
+      <p:pic>
+        <p:nvPicPr>
+          <p:cNvPr id="6" name="Picture 5" descr="diagram_usecase.png"/>
+          <p:cNvPicPr>
+            <a:picLocks noChangeAspect="1"/>
+          </p:cNvPicPr>
+          <p:nvPr/>
+        </p:nvPicPr>
+        <p:blipFill>
+          <a:blip r:embed="rId2"/>
+          <a:stretch>
+            <a:fillRect/>
+          </a:stretch>
+        </p:blipFill>
         <p:spPr>
           <a:xfrm>
             <a:off x="731520" y="1645920"/>
             <a:ext cx="5120640" cy="4480560"/>
           </a:xfrm>
-          <a:prstGeom prst="roundRect">
-            <a:avLst/>
-          </a:prstGeom>
-          <a:solidFill>
-            <a:srgbClr val="1E293B"/>
-          </a:solidFill>
-          <a:ln w="12700">
-            <a:solidFill>
-              <a:srgbClr val="334155"/>
-            </a:solidFill>
-          </a:ln>
-        </p:spPr>
-        <p:style>
-          <a:lnRef idx="1">
-            <a:schemeClr val="accent1"/>
-          </a:lnRef>
-          <a:fillRef idx="3">
-            <a:schemeClr val="accent1"/>
-          </a:fillRef>
-          <a:effectRef idx="2">
-            <a:schemeClr val="accent1"/>
-          </a:effectRef>
-          <a:fontRef idx="minor">
-            <a:schemeClr val="lt1"/>
-          </a:fontRef>
-        </p:style>
-        <p:txBody>
-          <a:bodyPr rtlCol="0" anchor="ctr"/>
-          <a:lstStyle/>
-          <a:p>
-            <a:pPr algn="ctr"/>
-          </a:p>
-        </p:txBody>
-      </p:sp>
-      <p:sp>
-        <p:nvSpPr>
-          <p:cNvPr id="7" name="TextBox 6"/>
-          <p:cNvSpPr txBox="1"/>
-          <p:nvPr/>
-        </p:nvSpPr>
-        <p:spPr>
-          <a:xfrm>
-            <a:off x="914400" y="1783080"/>
-            <a:ext cx="4754880" cy="365760"/>
-          </a:xfrm>
-          <a:prstGeom prst="rect">
-            <a:avLst/>
-          </a:prstGeom>
-          <a:noFill/>
-        </p:spPr>
-        <p:txBody>
-          <a:bodyPr wrap="square" lIns="0" tIns="0" rIns="0" bIns="0">
-            <a:spAutoFit/>
-          </a:bodyPr>
-          <a:lstStyle/>
-          <a:p>
-            <a:pPr>
-              <a:defRPr sz="1400" b="1">
-                <a:solidFill>
-                  <a:srgbClr val="06B6D4"/>
-                </a:solidFill>
-              </a:defRPr>
-            </a:pPr>
-            <a:r>
-              <a:t>THE EFFORT POINT SYSTEM</a:t>
-            </a:r>
-          </a:p>
-        </p:txBody>
-      </p:sp>
-      <p:sp>
-        <p:nvSpPr>
-          <p:cNvPr id="8" name="TextBox 7"/>
-          <p:cNvSpPr txBox="1"/>
-          <p:nvPr/>
-        </p:nvSpPr>
-        <p:spPr>
-          <a:xfrm>
-            <a:off x="914400" y="2194560"/>
-            <a:ext cx="4754880" cy="3749039"/>
-          </a:xfrm>
-          <a:prstGeom prst="rect">
-            <a:avLst/>
-          </a:prstGeom>
-          <a:noFill/>
-        </p:spPr>
-        <p:txBody>
-          <a:bodyPr wrap="square">
-            <a:spAutoFit/>
-          </a:bodyPr>
-          <a:lstStyle/>
-          <a:p>
-            <a:pPr>
-              <a:defRPr sz="1100">
-                <a:solidFill>
-                  <a:srgbClr val="F8FAFC"/>
-                </a:solidFill>
-              </a:defRPr>
-            </a:pPr>
-            <a:r>
-              <a:t>Eliminating Subjectivity in Household Duties:</a:t>
-            </a:r>
-            <a:br/>
-            <a:br/>
-            <a:r>
-              <a:t>In standard flatmates setups, simple binary chore counts treat 5 minutes of wiping a table the same as 1 hour of deep cleaning bathroom tiles.</a:t>
-            </a:r>
-            <a:br/>
-            <a:br/>
-            <a:r>
-              <a:t>HARMONY Effort Matrix:</a:t>
-            </a:r>
-            <a:br/>
-            <a:r>
-              <a:t>• Light Task (10 Points): Take out daily trash, sweep hallway.</a:t>
-            </a:r>
-            <a:br/>
-            <a:r>
-              <a:t>• Medium Task (20 Points): Wash shared kitchen dishes, grocery run.</a:t>
-            </a:r>
-            <a:br/>
-            <a:r>
-              <a:t>• Heavy Task (30 Points): Deep clean bathroom, mop living area.</a:t>
-            </a:r>
-            <a:br/>
-            <a:br/>
-            <a:r>
-              <a:t>Dynamic Leaderboard:</a:t>
-            </a:r>
-            <a:br/>
-            <a:r>
-              <a:t>Upon marking a chore 'Completed', the points are awarded to the responsible member. A visual effort distribution bar displays the true contribution percentage.</a:t>
-            </a:r>
-          </a:p>
-        </p:txBody>
-      </p:sp>
-      <p:sp>
-        <p:nvSpPr>
-          <p:cNvPr id="9" name="Rounded Rectangle 8"/>
-          <p:cNvSpPr/>
-          <p:nvPr/>
-        </p:nvSpPr>
+          <a:prstGeom prst="rect">
+            <a:avLst/>
+          </a:prstGeom>
+        </p:spPr>
+      </p:pic>
+      <p:pic>
+        <p:nvPicPr>
+          <p:cNvPr id="7" name="Picture 6" descr="diagram_flow.png"/>
+          <p:cNvPicPr>
+            <a:picLocks noChangeAspect="1"/>
+          </p:cNvPicPr>
+          <p:nvPr/>
+        </p:nvPicPr>
+        <p:blipFill>
+          <a:blip r:embed="rId3"/>
+          <a:stretch>
+            <a:fillRect/>
+          </a:stretch>
+        </p:blipFill>
         <p:spPr>
           <a:xfrm>
             <a:off x="6217920" y="1645920"/>
             <a:ext cx="5212080" cy="4480560"/>
           </a:xfrm>
-          <a:prstGeom prst="roundRect">
-            <a:avLst/>
-          </a:prstGeom>
-          <a:solidFill>
-            <a:srgbClr val="1E293B"/>
-          </a:solidFill>
-          <a:ln w="12700">
-            <a:solidFill>
-              <a:srgbClr val="334155"/>
-            </a:solidFill>
-          </a:ln>
-        </p:spPr>
-        <p:style>
-          <a:lnRef idx="1">
-            <a:schemeClr val="accent1"/>
-          </a:lnRef>
-          <a:fillRef idx="3">
-            <a:schemeClr val="accent1"/>
-          </a:fillRef>
-          <a:effectRef idx="2">
-            <a:schemeClr val="accent1"/>
-          </a:effectRef>
-          <a:fontRef idx="minor">
-            <a:schemeClr val="lt1"/>
-          </a:fontRef>
-        </p:style>
-        <p:txBody>
-          <a:bodyPr rtlCol="0" anchor="ctr"/>
-          <a:lstStyle/>
-          <a:p>
-            <a:pPr algn="ctr"/>
-          </a:p>
-        </p:txBody>
-      </p:sp>
-      <p:sp>
-        <p:nvSpPr>
-          <p:cNvPr id="10" name="TextBox 9"/>
-          <p:cNvSpPr txBox="1"/>
-          <p:nvPr/>
-        </p:nvSpPr>
-        <p:spPr>
-          <a:xfrm>
-            <a:off x="6400800" y="1783080"/>
-            <a:ext cx="4846320" cy="365760"/>
-          </a:xfrm>
-          <a:prstGeom prst="rect">
-            <a:avLst/>
-          </a:prstGeom>
-          <a:noFill/>
-        </p:spPr>
-        <p:txBody>
-          <a:bodyPr wrap="square" lIns="0" tIns="0" rIns="0" bIns="0">
-            <a:spAutoFit/>
-          </a:bodyPr>
-          <a:lstStyle/>
-          <a:p>
-            <a:pPr>
-              <a:defRPr sz="1400" b="1">
-                <a:solidFill>
-                  <a:srgbClr val="06B6D4"/>
-                </a:solidFill>
-              </a:defRPr>
-            </a:pPr>
-            <a:r>
-              <a:t>DUAL-METRIC BALANCE</a:t>
-            </a:r>
-          </a:p>
-        </p:txBody>
-      </p:sp>
-      <p:sp>
-        <p:nvSpPr>
-          <p:cNvPr id="11" name="TextBox 10"/>
-          <p:cNvSpPr txBox="1"/>
-          <p:nvPr/>
-        </p:nvSpPr>
-        <p:spPr>
-          <a:xfrm>
-            <a:off x="6400800" y="2194560"/>
-            <a:ext cx="4846320" cy="3749039"/>
-          </a:xfrm>
-          <a:prstGeom prst="rect">
-            <a:avLst/>
-          </a:prstGeom>
-          <a:noFill/>
-        </p:spPr>
-        <p:txBody>
-          <a:bodyPr wrap="square">
-            <a:spAutoFit/>
-          </a:bodyPr>
-          <a:lstStyle/>
-          <a:p>
-            <a:pPr>
-              <a:defRPr sz="1100">
-                <a:solidFill>
-                  <a:srgbClr val="F8FAFC"/>
-                </a:solidFill>
-              </a:defRPr>
-            </a:pPr>
-            <a:r>
-              <a:t>Holistic Roommate Equity:</a:t>
-            </a:r>
-            <a:br/>
-            <a:br/>
-            <a:r>
-              <a:t>HARMONY reconciles both sides of shared living:</a:t>
-            </a:r>
-            <a:br/>
-            <a:br/>
-            <a:r>
-              <a:t>1. Financial Contribution (Money):</a:t>
-            </a:r>
-            <a:br/>
-            <a:r>
-              <a:t>   Tracks rupee expenses to avoid monetary exploitation.</a:t>
-            </a:r>
-            <a:br/>
-            <a:br/>
-            <a:r>
-              <a:t>2. Physical Contribution (Labor):</a:t>
-            </a:r>
-            <a:br/>
-            <a:r>
-              <a:t>   Tracks effort points to avoid chore freeloading.</a:t>
-            </a:r>
-            <a:br/>
-            <a:br/>
-            <a:r>
-              <a:t>Balanced Household Example:</a:t>
-            </a:r>
-            <a:br/>
-            <a:r>
-              <a:t>If Flatmate A earns less but takes on 45% of high-point chores, while Flatmate B works late hours and covers utilities, both flatmates have complete, transparent visibility without emotional tension.</a:t>
-            </a:r>
-          </a:p>
-        </p:txBody>
-      </p:sp>
-      <p:sp>
-        <p:nvSpPr>
-          <p:cNvPr id="12" name="TextBox 11"/>
+          <a:prstGeom prst="rect">
+            <a:avLst/>
+          </a:prstGeom>
+        </p:spPr>
+      </p:pic>
+      <p:sp>
+        <p:nvSpPr>
+          <p:cNvPr id="8" name="TextBox 7"/>
           <p:cNvSpPr txBox="1"/>
           <p:nvPr/>
         </p:nvSpPr>
@@ -8178,7 +8735,7 @@
               </a:defRPr>
             </a:pPr>
             <a:r>
-              <a:t>HARMONY | Candidate: Lakshya Shukla (240919106121) | Guide: Mr. Nihal Kumar | IMS Noida (Panel 2 - Room DG4) | Slide 7 of 12</a:t>
+              <a:t>HARMONY | Candidate: Lakshya Shukla (240919106121) | Guide: Mr. Nihal Kumar | IMS Noida (Panel 2 - Room DG4) | Slide 7 of 14</a:t>
             </a:r>
           </a:p>
         </p:txBody>
@@ -8302,14 +8859,14 @@
           <a:lstStyle/>
           <a:p>
             <a:pPr>
-              <a:defRPr sz="2400" b="1">
+              <a:defRPr sz="2300" b="1">
                 <a:solidFill>
                   <a:srgbClr val="F8FAFC"/>
                 </a:solidFill>
               </a:defRPr>
             </a:pPr>
             <a:r>
-              <a:t>Modern UI Design &amp; Interactive Interface</a:t>
+              <a:t>Core Module 1: Automated Expense Splitting &amp; Ledger</a:t>
             </a:r>
           </a:p>
         </p:txBody>
@@ -8357,64 +8914,16 @@
           </a:p>
         </p:txBody>
       </p:sp>
-      <p:pic>
-        <p:nvPicPr>
-          <p:cNvPr id="6" name="Picture 5" descr="ui_landing.png"/>
-          <p:cNvPicPr>
-            <a:picLocks noChangeAspect="1"/>
-          </p:cNvPicPr>
-          <p:nvPr/>
-        </p:nvPicPr>
-        <p:blipFill>
-          <a:blip r:embed="rId2"/>
-          <a:stretch>
-            <a:fillRect/>
-          </a:stretch>
-        </p:blipFill>
+      <p:sp>
+        <p:nvSpPr>
+          <p:cNvPr id="6" name="Rounded Rectangle 5"/>
+          <p:cNvSpPr/>
+          <p:nvPr/>
+        </p:nvSpPr>
         <p:spPr>
           <a:xfrm>
             <a:off x="731520" y="1645920"/>
-            <a:ext cx="5120640" cy="2926080"/>
-          </a:xfrm>
-          <a:prstGeom prst="rect">
-            <a:avLst/>
-          </a:prstGeom>
-        </p:spPr>
-      </p:pic>
-      <p:pic>
-        <p:nvPicPr>
-          <p:cNvPr id="7" name="Picture 6" descr="ui_dashboard.png"/>
-          <p:cNvPicPr>
-            <a:picLocks noChangeAspect="1"/>
-          </p:cNvPicPr>
-          <p:nvPr/>
-        </p:nvPicPr>
-        <p:blipFill>
-          <a:blip r:embed="rId3"/>
-          <a:stretch>
-            <a:fillRect/>
-          </a:stretch>
-        </p:blipFill>
-        <p:spPr>
-          <a:xfrm>
-            <a:off x="6217920" y="1645920"/>
-            <a:ext cx="5212080" cy="2926080"/>
-          </a:xfrm>
-          <a:prstGeom prst="rect">
-            <a:avLst/>
-          </a:prstGeom>
-        </p:spPr>
-      </p:pic>
-      <p:sp>
-        <p:nvSpPr>
-          <p:cNvPr id="8" name="Rounded Rectangle 7"/>
-          <p:cNvSpPr/>
-          <p:nvPr/>
-        </p:nvSpPr>
-        <p:spPr>
-          <a:xfrm>
-            <a:off x="731520" y="4754880"/>
-            <a:ext cx="5120640" cy="1463040"/>
+            <a:ext cx="5120640" cy="4480560"/>
           </a:xfrm>
           <a:prstGeom prst="roundRect">
             <a:avLst/>
@@ -8452,13 +8961,13 @@
       </p:sp>
       <p:sp>
         <p:nvSpPr>
-          <p:cNvPr id="9" name="TextBox 8"/>
+          <p:cNvPr id="7" name="TextBox 6"/>
           <p:cNvSpPr txBox="1"/>
           <p:nvPr/>
         </p:nvSpPr>
         <p:spPr>
           <a:xfrm>
-            <a:off x="914400" y="4892040"/>
+            <a:off x="914400" y="1783080"/>
             <a:ext cx="4754880" cy="365760"/>
           </a:xfrm>
           <a:prstGeom prst="rect">
@@ -8473,28 +8982,28 @@
           <a:lstStyle/>
           <a:p>
             <a:pPr>
-              <a:defRPr sz="1400" b="1">
+              <a:defRPr sz="1300" b="1">
                 <a:solidFill>
                   <a:srgbClr val="06B6D4"/>
                 </a:solidFill>
               </a:defRPr>
             </a:pPr>
             <a:r>
-              <a:t>LANDING PAGE &amp; ONBOARDING</a:t>
-            </a:r>
-          </a:p>
-        </p:txBody>
-      </p:sp>
-      <p:sp>
-        <p:nvSpPr>
-          <p:cNvPr id="10" name="TextBox 9"/>
+              <a:t>MATHEMATICAL SPLIT FORMULATION</a:t>
+            </a:r>
+          </a:p>
+        </p:txBody>
+      </p:sp>
+      <p:sp>
+        <p:nvSpPr>
+          <p:cNvPr id="8" name="TextBox 7"/>
           <p:cNvSpPr txBox="1"/>
           <p:nvPr/>
         </p:nvSpPr>
         <p:spPr>
           <a:xfrm>
-            <a:off x="914400" y="5120640"/>
-            <a:ext cx="4754880" cy="1005840"/>
+            <a:off x="914400" y="2194560"/>
+            <a:ext cx="4754880" cy="3749039"/>
           </a:xfrm>
           <a:prstGeom prst="rect">
             <a:avLst/>
@@ -8508,28 +9017,73 @@
           <a:lstStyle/>
           <a:p>
             <a:pPr>
-              <a:defRPr sz="1000">
+              <a:defRPr sz="1100">
                 <a:solidFill>
                   <a:srgbClr val="F8FAFC"/>
                 </a:solidFill>
               </a:defRPr>
             </a:pPr>
             <a:r>
-              <a:t>Clean, professional dark-mode design highlighting core value propositions, feature highlights, and frictionless authentication.</a:t>
-            </a:r>
-          </a:p>
-        </p:txBody>
-      </p:sp>
-      <p:sp>
-        <p:nvSpPr>
-          <p:cNvPr id="11" name="Rounded Rectangle 10"/>
+              <a:t>Mathematical Principle of Ledger Equilibrium:</a:t>
+            </a:r>
+            <a:br/>
+            <a:br/>
+            <a:r>
+              <a:t>For any household member i:</a:t>
+            </a:r>
+            <a:br/>
+            <a:r>
+              <a:t>   Net Balance (B_i) = Total Amount Paid (P_i) - Expected Share (S_i)</a:t>
+            </a:r>
+            <a:br/>
+            <a:br/>
+            <a:r>
+              <a:t>Equilibrium Invariant:</a:t>
+            </a:r>
+            <a:br/>
+            <a:r>
+              <a:t>   Sum of all B_i across household = 0</a:t>
+            </a:r>
+            <a:br/>
+            <a:br/>
+            <a:r>
+              <a:t>• Positive Net Balance (+₹X):</a:t>
+            </a:r>
+            <a:br/>
+            <a:r>
+              <a:t>  The member has paid more than their equal share. The group owes this member ₹X. Displayed in Emerald Green.</a:t>
+            </a:r>
+            <a:br/>
+            <a:br/>
+            <a:r>
+              <a:t>• Negative Net Balance (-₹Y):</a:t>
+            </a:r>
+            <a:br/>
+            <a:r>
+              <a:t>  The member has undercontributed or paid less than their share. This member owes ₹Y to the group. Displayed in Amber/Rose.</a:t>
+            </a:r>
+            <a:br/>
+            <a:br/>
+            <a:r>
+              <a:t>• Zero Net Balance (₹0):</a:t>
+            </a:r>
+            <a:br/>
+            <a:r>
+              <a:t>  The member's dues are perfectly settled.</a:t>
+            </a:r>
+          </a:p>
+        </p:txBody>
+      </p:sp>
+      <p:sp>
+        <p:nvSpPr>
+          <p:cNvPr id="9" name="Rounded Rectangle 8"/>
           <p:cNvSpPr/>
           <p:nvPr/>
         </p:nvSpPr>
         <p:spPr>
           <a:xfrm>
-            <a:off x="6217920" y="4754880"/>
-            <a:ext cx="5212080" cy="1463040"/>
+            <a:off x="6217920" y="1645920"/>
+            <a:ext cx="5212080" cy="4480560"/>
           </a:xfrm>
           <a:prstGeom prst="roundRect">
             <a:avLst/>
@@ -8567,13 +9121,13 @@
       </p:sp>
       <p:sp>
         <p:nvSpPr>
-          <p:cNvPr id="12" name="TextBox 11"/>
+          <p:cNvPr id="10" name="TextBox 9"/>
           <p:cNvSpPr txBox="1"/>
           <p:nvPr/>
         </p:nvSpPr>
         <p:spPr>
           <a:xfrm>
-            <a:off x="6400800" y="4892040"/>
+            <a:off x="6400800" y="1783080"/>
             <a:ext cx="4846320" cy="365760"/>
           </a:xfrm>
           <a:prstGeom prst="rect">
@@ -8588,28 +9142,28 @@
           <a:lstStyle/>
           <a:p>
             <a:pPr>
-              <a:defRPr sz="1400" b="1">
+              <a:defRPr sz="1300" b="1">
                 <a:solidFill>
                   <a:srgbClr val="06B6D4"/>
                 </a:solidFill>
               </a:defRPr>
             </a:pPr>
             <a:r>
-              <a:t>ROOMMATE LIVE DASHBOARD</a:t>
-            </a:r>
-          </a:p>
-        </p:txBody>
-      </p:sp>
-      <p:sp>
-        <p:nvSpPr>
-          <p:cNvPr id="13" name="TextBox 12"/>
+              <a:t>EXPENSE ENGINE CAPABILITIES</a:t>
+            </a:r>
+          </a:p>
+        </p:txBody>
+      </p:sp>
+      <p:sp>
+        <p:nvSpPr>
+          <p:cNvPr id="11" name="TextBox 10"/>
           <p:cNvSpPr txBox="1"/>
           <p:nvPr/>
         </p:nvSpPr>
         <p:spPr>
           <a:xfrm>
-            <a:off x="6400800" y="5120640"/>
-            <a:ext cx="4846320" cy="1005840"/>
+            <a:off x="6400800" y="2194560"/>
+            <a:ext cx="4846320" cy="3749039"/>
           </a:xfrm>
           <a:prstGeom prst="rect">
             <a:avLst/>
@@ -8623,21 +9177,61 @@
           <a:lstStyle/>
           <a:p>
             <a:pPr>
-              <a:defRPr sz="1000">
+              <a:defRPr sz="1100">
                 <a:solidFill>
                   <a:srgbClr val="F8FAFC"/>
                 </a:solidFill>
               </a:defRPr>
             </a:pPr>
             <a:r>
-              <a:t>Real-time Net Balance card, Effort Leaderboard, Pending vs Completed chores, and recent shared bills with one-click actions.</a:t>
-            </a:r>
-          </a:p>
-        </p:txBody>
-      </p:sp>
-      <p:sp>
-        <p:nvSpPr>
-          <p:cNvPr id="14" name="TextBox 13"/>
+              <a:t>Operational Workflow:</a:t>
+            </a:r>
+            <a:br/>
+            <a:br/>
+            <a:r>
+              <a:t>1. Bill Recording:</a:t>
+            </a:r>
+            <a:br/>
+            <a:r>
+              <a:t>   Roommate records expense (e.g. ₹2,400 for Fiber Internet, paid by Lakshya Shukla).</a:t>
+            </a:r>
+            <a:br/>
+            <a:br/>
+            <a:r>
+              <a:t>2. Split Computation:</a:t>
+            </a:r>
+            <a:br/>
+            <a:r>
+              <a:t>   System divides amount equally across all 4 household occupants: ₹600 per occupant.</a:t>
+            </a:r>
+            <a:br/>
+            <a:br/>
+            <a:r>
+              <a:t>3. Ledger Update:</a:t>
+            </a:r>
+            <a:br/>
+            <a:r>
+              <a:t>   • Lakshya Paid: ₹2,400 | Share: ₹600 | Net Balance: +₹1,800</a:t>
+            </a:r>
+            <a:br/>
+            <a:r>
+              <a:t>   • Other 3 Roommates: Paid: ₹0 | Share: ₹600 | Net Balance: -₹600 each</a:t>
+            </a:r>
+            <a:br/>
+            <a:br/>
+            <a:r>
+              <a:t>4. Transparent History:</a:t>
+            </a:r>
+            <a:br/>
+            <a:r>
+              <a:t>   Categorized under Groceries, Utilities, Internet, Supplies with exact timestamps and payer tags.</a:t>
+            </a:r>
+          </a:p>
+        </p:txBody>
+      </p:sp>
+      <p:sp>
+        <p:nvSpPr>
+          <p:cNvPr id="12" name="TextBox 11"/>
           <p:cNvSpPr txBox="1"/>
           <p:nvPr/>
         </p:nvSpPr>
@@ -8665,7 +9259,7 @@
               </a:defRPr>
             </a:pPr>
             <a:r>
-              <a:t>HARMONY | Candidate: Lakshya Shukla (240919106121) | Guide: Mr. Nihal Kumar | IMS Noida (Panel 2 - Room DG4) | Slide 8 of 12</a:t>
+              <a:t>HARMONY | Candidate: Lakshya Shukla (240919106121) | Guide: Mr. Nihal Kumar | IMS Noida (Panel 2 - Room DG4) | Slide 8 of 14</a:t>
             </a:r>
           </a:p>
         </p:txBody>
@@ -8789,14 +9383,14 @@
           <a:lstStyle/>
           <a:p>
             <a:pPr>
-              <a:defRPr sz="2400" b="1">
+              <a:defRPr sz="2300" b="1">
                 <a:solidFill>
                   <a:srgbClr val="F8FAFC"/>
                 </a:solidFill>
               </a:defRPr>
             </a:pPr>
             <a:r>
-              <a:t>Role-Based Access Control (RBAC) &amp; Governance</a:t>
+              <a:t>Core Module 2: Effort-Weighted Chore Allocation</a:t>
             </a:r>
           </a:p>
         </p:txBody>
@@ -8844,40 +9438,16 @@
           </a:p>
         </p:txBody>
       </p:sp>
-      <p:pic>
-        <p:nvPicPr>
-          <p:cNvPr id="6" name="Picture 5" descr="ui_admin.png"/>
-          <p:cNvPicPr>
-            <a:picLocks noChangeAspect="1"/>
-          </p:cNvPicPr>
-          <p:nvPr/>
-        </p:nvPicPr>
-        <p:blipFill>
-          <a:blip r:embed="rId2"/>
-          <a:stretch>
-            <a:fillRect/>
-          </a:stretch>
-        </p:blipFill>
+      <p:sp>
+        <p:nvSpPr>
+          <p:cNvPr id="6" name="Rounded Rectangle 5"/>
+          <p:cNvSpPr/>
+          <p:nvPr/>
+        </p:nvSpPr>
         <p:spPr>
           <a:xfrm>
             <a:off x="731520" y="1645920"/>
-            <a:ext cx="5486400" cy="4480560"/>
-          </a:xfrm>
-          <a:prstGeom prst="rect">
-            <a:avLst/>
-          </a:prstGeom>
-        </p:spPr>
-      </p:pic>
-      <p:sp>
-        <p:nvSpPr>
-          <p:cNvPr id="7" name="Rounded Rectangle 6"/>
-          <p:cNvSpPr/>
-          <p:nvPr/>
-        </p:nvSpPr>
-        <p:spPr>
-          <a:xfrm>
-            <a:off x="6492240" y="1645920"/>
-            <a:ext cx="4937760" cy="4480560"/>
+            <a:ext cx="5120640" cy="4480560"/>
           </a:xfrm>
           <a:prstGeom prst="roundRect">
             <a:avLst/>
@@ -8915,14 +9485,14 @@
       </p:sp>
       <p:sp>
         <p:nvSpPr>
-          <p:cNvPr id="8" name="TextBox 7"/>
+          <p:cNvPr id="7" name="TextBox 6"/>
           <p:cNvSpPr txBox="1"/>
           <p:nvPr/>
         </p:nvSpPr>
         <p:spPr>
           <a:xfrm>
-            <a:off x="6675120" y="1783080"/>
-            <a:ext cx="4572000" cy="365760"/>
+            <a:off x="914400" y="1783080"/>
+            <a:ext cx="4754880" cy="365760"/>
           </a:xfrm>
           <a:prstGeom prst="rect">
             <a:avLst/>
@@ -8936,28 +9506,28 @@
           <a:lstStyle/>
           <a:p>
             <a:pPr>
-              <a:defRPr sz="1400" b="1">
+              <a:defRPr sz="1300" b="1">
                 <a:solidFill>
                   <a:srgbClr val="06B6D4"/>
                 </a:solidFill>
               </a:defRPr>
             </a:pPr>
             <a:r>
-              <a:t>GOVERNANCE &amp; PERMISSIONS</a:t>
-            </a:r>
-          </a:p>
-        </p:txBody>
-      </p:sp>
-      <p:sp>
-        <p:nvSpPr>
-          <p:cNvPr id="9" name="TextBox 8"/>
+              <a:t>THE EFFORT POINT SYSTEM</a:t>
+            </a:r>
+          </a:p>
+        </p:txBody>
+      </p:sp>
+      <p:sp>
+        <p:nvSpPr>
+          <p:cNvPr id="8" name="TextBox 7"/>
           <p:cNvSpPr txBox="1"/>
           <p:nvPr/>
         </p:nvSpPr>
         <p:spPr>
           <a:xfrm>
-            <a:off x="6675120" y="2194560"/>
-            <a:ext cx="4572000" cy="3749039"/>
+            <a:off x="914400" y="2194560"/>
+            <a:ext cx="4754880" cy="3749039"/>
           </a:xfrm>
           <a:prstGeom prst="rect">
             <a:avLst/>
@@ -8971,65 +9541,199 @@
           <a:lstStyle/>
           <a:p>
             <a:pPr>
-              <a:defRPr sz="1050">
+              <a:defRPr sz="1100">
                 <a:solidFill>
                   <a:srgbClr val="F8FAFC"/>
                 </a:solidFill>
               </a:defRPr>
             </a:pPr>
             <a:r>
-              <a:t>Role Hierarchy:</a:t>
-            </a:r>
-            <a:br/>
-            <a:br/>
-            <a:r>
-              <a:t>• Household Admin (Primary Householder):</a:t>
-            </a:r>
-            <a:br/>
-            <a:r>
-              <a:t>  Can create households, issue invite codes, assign chores, remove flatmates, and settle dispute adjustments.</a:t>
-            </a:r>
-            <a:br/>
-            <a:br/>
-            <a:r>
-              <a:t>• Household Member:</a:t>
-            </a:r>
-            <a:br/>
-            <a:r>
-              <a:t>  Can view dashboard, log new bills, claim/complete chores, and inspect net balances.</a:t>
-            </a:r>
-            <a:br/>
-            <a:br/>
-            <a:r>
-              <a:t>• System SuperAdmin:</a:t>
-            </a:r>
-            <a:br/>
-            <a:r>
-              <a:t>  Full audit visibility across all households, system health, and database purge tools.</a:t>
-            </a:r>
-            <a:br/>
-            <a:br/>
-            <a:r>
-              <a:t>Security Protections:</a:t>
-            </a:r>
-            <a:br/>
-            <a:r>
-              <a:t>• Input sanitization against XSS and SQL injection.</a:t>
-            </a:r>
-            <a:br/>
-            <a:r>
-              <a:t>• JWT / Bearer Token authorization verification.</a:t>
-            </a:r>
-            <a:br/>
-            <a:r>
-              <a:t>• Strict household tenancy isolation (members cannot view expenses of other households).</a:t>
-            </a:r>
+              <a:t>Eliminating Subjectivity in Household Duties:</a:t>
+            </a:r>
+            <a:br/>
+            <a:br/>
+            <a:r>
+              <a:t>In standard flatmates setups, simple binary chore counts treat 5 minutes of wiping a table the same as 1 hour of deep cleaning bathroom tiles.</a:t>
+            </a:r>
+            <a:br/>
+            <a:br/>
+            <a:r>
+              <a:t>HARMONY Effort Matrix:</a:t>
+            </a:r>
+            <a:br/>
+            <a:r>
+              <a:t>• Light Task (10 Points): Take out daily trash, sweep hallway.</a:t>
+            </a:r>
+            <a:br/>
+            <a:r>
+              <a:t>• Medium Task (20 Points): Wash shared kitchen dishes, grocery run.</a:t>
+            </a:r>
+            <a:br/>
+            <a:r>
+              <a:t>• Heavy Task (30 Points): Deep clean bathroom, mop living area.</a:t>
+            </a:r>
+            <a:br/>
+            <a:br/>
+            <a:r>
+              <a:t>Dynamic Leaderboard:</a:t>
+            </a:r>
+            <a:br/>
+            <a:r>
+              <a:t>Upon marking a chore 'Completed', the points are awarded to the responsible member. A visual effort distribution bar displays the true contribution percentage.</a:t>
+            </a:r>
+          </a:p>
+        </p:txBody>
+      </p:sp>
+      <p:sp>
+        <p:nvSpPr>
+          <p:cNvPr id="9" name="Rounded Rectangle 8"/>
+          <p:cNvSpPr/>
+          <p:nvPr/>
+        </p:nvSpPr>
+        <p:spPr>
+          <a:xfrm>
+            <a:off x="6217920" y="1645920"/>
+            <a:ext cx="5212080" cy="4480560"/>
+          </a:xfrm>
+          <a:prstGeom prst="roundRect">
+            <a:avLst/>
+          </a:prstGeom>
+          <a:solidFill>
+            <a:srgbClr val="1E293B"/>
+          </a:solidFill>
+          <a:ln w="12700">
+            <a:solidFill>
+              <a:srgbClr val="334155"/>
+            </a:solidFill>
+          </a:ln>
+        </p:spPr>
+        <p:style>
+          <a:lnRef idx="1">
+            <a:schemeClr val="accent1"/>
+          </a:lnRef>
+          <a:fillRef idx="3">
+            <a:schemeClr val="accent1"/>
+          </a:fillRef>
+          <a:effectRef idx="2">
+            <a:schemeClr val="accent1"/>
+          </a:effectRef>
+          <a:fontRef idx="minor">
+            <a:schemeClr val="lt1"/>
+          </a:fontRef>
+        </p:style>
+        <p:txBody>
+          <a:bodyPr rtlCol="0" anchor="ctr"/>
+          <a:lstStyle/>
+          <a:p>
+            <a:pPr algn="ctr"/>
           </a:p>
         </p:txBody>
       </p:sp>
       <p:sp>
         <p:nvSpPr>
           <p:cNvPr id="10" name="TextBox 9"/>
+          <p:cNvSpPr txBox="1"/>
+          <p:nvPr/>
+        </p:nvSpPr>
+        <p:spPr>
+          <a:xfrm>
+            <a:off x="6400800" y="1783080"/>
+            <a:ext cx="4846320" cy="365760"/>
+          </a:xfrm>
+          <a:prstGeom prst="rect">
+            <a:avLst/>
+          </a:prstGeom>
+          <a:noFill/>
+        </p:spPr>
+        <p:txBody>
+          <a:bodyPr wrap="square" lIns="0" tIns="0" rIns="0" bIns="0">
+            <a:spAutoFit/>
+          </a:bodyPr>
+          <a:lstStyle/>
+          <a:p>
+            <a:pPr>
+              <a:defRPr sz="1300" b="1">
+                <a:solidFill>
+                  <a:srgbClr val="06B6D4"/>
+                </a:solidFill>
+              </a:defRPr>
+            </a:pPr>
+            <a:r>
+              <a:t>DUAL-METRIC BALANCE</a:t>
+            </a:r>
+          </a:p>
+        </p:txBody>
+      </p:sp>
+      <p:sp>
+        <p:nvSpPr>
+          <p:cNvPr id="11" name="TextBox 10"/>
+          <p:cNvSpPr txBox="1"/>
+          <p:nvPr/>
+        </p:nvSpPr>
+        <p:spPr>
+          <a:xfrm>
+            <a:off x="6400800" y="2194560"/>
+            <a:ext cx="4846320" cy="3749039"/>
+          </a:xfrm>
+          <a:prstGeom prst="rect">
+            <a:avLst/>
+          </a:prstGeom>
+          <a:noFill/>
+        </p:spPr>
+        <p:txBody>
+          <a:bodyPr wrap="square">
+            <a:spAutoFit/>
+          </a:bodyPr>
+          <a:lstStyle/>
+          <a:p>
+            <a:pPr>
+              <a:defRPr sz="1100">
+                <a:solidFill>
+                  <a:srgbClr val="F8FAFC"/>
+                </a:solidFill>
+              </a:defRPr>
+            </a:pPr>
+            <a:r>
+              <a:t>Holistic Roommate Equity:</a:t>
+            </a:r>
+            <a:br/>
+            <a:br/>
+            <a:r>
+              <a:t>HARMONY reconciles both sides of shared living:</a:t>
+            </a:r>
+            <a:br/>
+            <a:br/>
+            <a:r>
+              <a:t>1. Financial Contribution (Money):</a:t>
+            </a:r>
+            <a:br/>
+            <a:r>
+              <a:t>   Tracks rupee expenses to avoid monetary exploitation.</a:t>
+            </a:r>
+            <a:br/>
+            <a:br/>
+            <a:r>
+              <a:t>2. Physical Contribution (Labor):</a:t>
+            </a:r>
+            <a:br/>
+            <a:r>
+              <a:t>   Tracks effort points to avoid chore freeloading.</a:t>
+            </a:r>
+            <a:br/>
+            <a:br/>
+            <a:r>
+              <a:t>Balanced Household Example:</a:t>
+            </a:r>
+            <a:br/>
+            <a:r>
+              <a:t>If Flatmate A earns less but takes on 45% of high-point chores, while Flatmate B works late hours and covers utilities, both flatmates have complete, transparent visibility without emotional tension.</a:t>
+            </a:r>
+          </a:p>
+        </p:txBody>
+      </p:sp>
+      <p:sp>
+        <p:nvSpPr>
+          <p:cNvPr id="12" name="TextBox 11"/>
           <p:cNvSpPr txBox="1"/>
           <p:nvPr/>
         </p:nvSpPr>
@@ -9057,7 +9761,7 @@
               </a:defRPr>
             </a:pPr>
             <a:r>
-              <a:t>HARMONY | Candidate: Lakshya Shukla (240919106121) | Guide: Mr. Nihal Kumar | IMS Noida (Panel 2 - Room DG4) | Slide 9 of 12</a:t>
+              <a:t>HARMONY | Candidate: Lakshya Shukla (240919106121) | Guide: Mr. Nihal Kumar | IMS Noida (Panel 2 - Room DG4) | Slide 9 of 14</a:t>
             </a:r>
           </a:p>
         </p:txBody>

</xml_diff>